<commit_message>
Decks de Basico 1 y 2 con imagenes: 225 dibujos de la casa y diseno de laminas revisado
- 225 imagenes en Curriculo/fuente/decks/img/<B1S1..B2S8>/ (dibujos SVG en el estilo de
  las flashcards, flashcards reutilizadas, retrato de Sejong del material propio y captura
  del Lector), con map.json por deck; 5 quedan pendientes para Jay (fotos propias, Kiran,
  famosos, capturas de Zoom)
- Generador: imagen de lamina en panel, miniaturas por item, ejercicios en tarjetas grandes
  cuando todos los items traen imagen, imagen por glifo, palabra y columna; mismo tamano de
  hangul en todas las tarjetas; frase.destacar; portadas que no se montan; sin cortes en
  천 원, 할 수 있다 ni series de jamo
- Herramientas en img_tools/ (render, check sin rojo ni rosado, hoja de contacto) y guia
- Dos rondas de control visual adversarial; vistas previas _png fuera de git

Co-Authored-By: Claude Opus 5.5 <noreply@anthropic.com>
</commit_message>
<xml_diff>
--- a/Curriculo/Fase2_Basico1/decks/Basico1_S02_Kiran.pptx
+++ b/Curriculo/Fase2_Basico1/decks/Basico1_S02_Kiran.pptx
@@ -138,7 +138,7 @@
   <p:extLst>
     <p:ext uri="{521415D9-36F7-43E2-AB2F-B90AF26B5E84}">
       <p14:sectionLst xmlns:p14="http://schemas.microsoft.com/office/powerpoint/2010/main">
-        <p14:section name="Semana 2" id="{65796394-B693-4A57-6AAB-AD1D0FE8D5D6}">
+        <p14:section name="Semana 2" id="{C3D02844-806D-F348-058E-460CEF79A51D}">
           <p14:sldIdLst>
             <p14:sldId id="256"/>
             <p14:sldId id="257"/>
@@ -208,7 +208,7 @@
     </p:spTree>
     <p:extLst>
       <p:ext uri="{BB962C8B-B14F-4D97-AF65-F5344CB8AC3E}">
-        <p14:creationId xmlns:p14="http://schemas.microsoft.com/office/powerpoint/2010/main" val="3503475029"/>
+        <p14:creationId xmlns:p14="http://schemas.microsoft.com/office/powerpoint/2010/main" val="997456857"/>
       </p:ext>
     </p:extLst>
   </p:cSld>
@@ -355,7 +355,6 @@
             <a:r>
               <a:rPr lang="en-US" dirty="0"/>
               <a:t>20:00, 30 s. Grabación en la nube ya activa (Basico1-Martes_S02_2026-10-20 o Basico1-Jueves_S02_2026-10-22). Haz 목례 a la cámara: «안녕하세요!» y espera el 안녕하세요 de vuelta. Si alguien dice 안녕, sonríe y déjalo para el bloque de cultura.
-Imagen sugerida: Logo azul de Academia Seúl (plantilla de la casa)
 Fuente: Nueva
 Lámina 1</a:t>
             </a:r>
@@ -712,7 +711,7 @@
             <a:r>
               <a:rPr lang="en-US" dirty="0"/>
               <a:t>20:16. «Ahora solo escuchen, todavía no repitan.» Haz 목례 y di: «안녕하세요! 저는 기란이에요. 한국 사람이에요. 선생님이에요.» (⚑ 선생님 lleva 님, que es respeto hacia otro; para uno mismo lo más cuidado es 한국어 선생님이에요 o 교사예요, pero se oye mucho y lo usamos por ser vocabulario núcleo: D, punto 7).
-Imagen sugerida: Foto de Kiran (del clip de Kiran o del post "Conoce a tus profes")
+Imagen pendiente: Foto de Kiran sonriendo, sin rótulos encima, para la derecha de la lámina. Lo más rápido: recortar la parte de arriba de Campana_Assets/instagram/octubre/reels/kiran/Reel_Kiran_portada.png (de la frente al pecho, sin «CONOCE A TU PROFE» ni «KIRAN · 기란» ni el degradado navy), en proporción vertical 425:490 (p. ej. 850 × 980 px), o usar una foto que mande ella. Guardarla como Curriculo/fuente/decks/img/B1S2/L13_slide.jpg y sumar al map.json {"L":"13","destino":"slide","indice":0,"archivo":"L13_slide.jpg","origen":"material_propio"} (o pegarla a mano en PowerPoint). Antes, confirmar con Kiran que le gusta la foto.
 Fuente: Nueva (foto del clip de Kiran o del post "Conoce a tus profes")
 Lámina 13</a:t>
             </a:r>
@@ -802,7 +801,7 @@
             <a:r>
               <a:rPr lang="en-US" dirty="0"/>
               <a:t>20:17. «Y ahora me voy a convertir en tres famosos»: muestra cada foto y di su frase. Pregunta de detective en el chat: «¿Qué palabra dije siempre al principio? (저는) ¿Y con qué terminé siempre? (이에요 o 예요) ¿Cuándo dije 이에요 y cuándo 예요?» Deja 30 s: alguien va a notar que 샤키라 termina en vocal. Si vas atrasada, solo 샤키라 (la de 예요).
-Imagen sugerida: 3 fotos con licencia libre (Wikimedia Commons) o ilustraciones de Son Heung-min, Shakira y Pedro Pascal; nunca capturas de buscador
+Imagen pendiente: 3 fotos con licencia libre de Wikimedia Commons (dominio público, CC BY o CC BY-SA) de Son Heung-min, Shakira y Pedro Pascal, en ese orden (columna 1, 2 y 3). Recortar cada una a lo ancho en proporción 2,2:1 (p. ej. 880 × 400 px) con la cara centrada y guardarlas como Curriculo/fuente/decks/img/B1S2/L14_col0.jpg, L14_col1.jpg y L14_col2.jpg; sumarlas al map.json con destino col e indice 0, 1 y 2 (o pegarlas a mano arriba de cada columna). Poner autor y licencia de cada foto en las notas del orador. Nunca capturas de buscador ni fotos de prensa o de agencias. Evitar fotos donde domine el rojo (p. ej. Son con la camiseta roja de la selección): mejor camiseta blanca u oscura, o recortar a la cara. Si no aparece una foto libre de alguno, dejar esa columna sin foto: la lámina funciona igual con los nombres.
 Fuente: Nueva · ⚑ grafías de los famosos (D, punto 2)
 Lámina 14</a:t>
             </a:r>
@@ -1159,7 +1158,7 @@
             <a:r>
               <a:rPr lang="en-US" dirty="0"/>
               <a:t>20:21–20:22. «Para decir tu país: país + 사람, "persona de". 칠레 사람: chileno o chilena, no hay masculino ni femenino. Y como 사람 termina en 받침, siempre es 사람이에요.» Coro: «칠레 사람이에요 · 멕시코 사람이에요 · 콜롬비아 사람이에요 · 한국 사람이에요.» A las 20:27 vuelves aquí para el coro de transformación: muestras 콜롬비아 → «콜롬비아 사람이에요!», 페루 → «페루 사람이에요!». Otros países, a pedido (tarjeta de países, ⚑).
-Imagen sugerida: Sin banderas (y sin rojo): cada tarjeta con el nombre del país o un ícono neutro
+Imagen: incluida (dibujo de la casa).
 Fuente: Sesion_03_Saludos.pptx lám. 21–23: dejar solo estas palabras (베네수엘라 y el resto pasan a "a pedido")
 Lámina 18a</a:t>
             </a:r>
@@ -1249,7 +1248,7 @@
             <a:r>
               <a:rPr lang="en-US" dirty="0"/>
               <a:t>20:22. «Ocupaciones, también sin género: 학생, 선생님, 회사원, 의사. ¿Cuáles llevan 이에요?» (학생, 선생님, 회사원) «¿Y cuál 예요?» (의사). «Si tu ocupación no está, me la preguntas; y si no quieres decirla, basta con nombre y país.» En el coro de transformación (20:27): 의사 → «의사예요!», 회사원 → «회사원이에요!»; y despedidas con gesto: te levantas y sales del cuadro → «안녕히 가세요!»; te quedas y ellos "caminan" con los dedos → «안녕히 계세요!».
-Imagen sugerida: Íconos de las cuatro ocupaciones (estudiante, profesora, oficina, médico)
+Imagen: incluida (dibujo de la casa).
 Fuente: Sesion_03_Saludos.pptx lám. 21–23: dejar solo estas cuatro ocupaciones
 Lámina 18b</a:t>
             </a:r>
@@ -1695,7 +1694,7 @@
             <a:r>
               <a:rPr lang="en-US" dirty="0"/>
               <a:t>20:23–20:24. «Cuando se saluda en Corea, se inclina la cabeza: 목례. Con la profe o con una persona mayor, un poco más marcado y con el 안녕하세요 completo. Entre amigos de la misma edad, lo normal es 안녕 (y también se le dice a un niño o a alguien menor con quien hay confianza). Con un mayor, no. Por eso en esta clase: 안녕하세요.» Matiz [YA]: di "normalmente", nunca "nunca".
-Imagen sugerida: Dibujo de una leve inclinación de cabeza (목례)
+Imagen: incluida (dibujo de la casa).
 Fuente: Nueva (no usar la lám. 7 de Sesion_03_Saludos.pptx, "En Corea NO se dan la mano": generaliza)
 Lámina 20</a:t>
             </a:r>
@@ -1785,7 +1784,7 @@
             <a:r>
               <a:rPr lang="en-US" dirty="0"/>
               <a:t>20:24–20:25. «Nuestro "chao" sirve para todo. En coreano depende de quién se va. 가다 es "ir": 안녕히 가세요 es "váyase bien", y se lo dices a quien se va. 계세요 es "quédese": 안녕히 계세요, a quien se queda. ¿Les suena? Es nuestro "que te vaya bien".» «Y si los dos se van, por ejemplo en la calle, los dos dicen 안녕히 가세요.» «Al final de nuestra clase, ustedes se van y yo me quedo: me van a decir 안녕히 계세요, y yo les digo 안녕히 가세요» (⚑ D, punto 1).
-Imagen sugerida: Dibujo de una puerta: la persona que sale (안녕히 가세요) y la que se queda (안녕히 계세요)
+Imagen: incluida (dibujo de la casa).
 Fuente: Adaptar lám. 3 y 8 de Sesion_03_Saludos.pptx (quitar [AN-NIONG-JI…], 고마워요, 죄송합니다, 잘 먹겠습니다)
 Lámina 21</a:t>
             </a:r>
@@ -2587,7 +2586,7 @@
             <a:r>
               <a:rPr lang="en-US" dirty="0"/>
               <a:t>Solo si sobran 2–5 minutos (lámina oculta si no se usa). Lectura en voz alta por turnos, sin significado: «ya pueden leer un menú», que es la promesa publicada del curso ("leer en voz alta un cartel o un menú"). Otra emergencia posible: ping-pong de 받침 con los pares 안/앙 · 암/앙 · 곰/공 · 밥/방 (dices una sílaba y el grupo responde en el chat solo la consonante final).
-Imagen sugerida: Pizarra de menú de restaurante coreano diseñada por nosotros (texto tipeado, no foto de internet), sin precios ni romanización
+Imagen: incluida (dibujo de la casa).
 Fuente: Nueva (después de la 28; oculta si no se usa)
 Lámina 29</a:t>
             </a:r>
@@ -2766,7 +2765,7 @@
             <a:r>
               <a:rPr lang="en-US" dirty="0"/>
               <a:t>20:05–20:06. «Hasta ahora todas las sílabas terminaban en vocal: 가, 나, 무. Hoy les ponemos un piso más abajo: una consonante al final. Eso se llama 받침, "lo que sostiene". 가 más ㅇ abajo: 강. 바 más ㅂ abajo: 밥.» «Regla de oro: después del 받침 no hay vocal. En español nos sale agregar una: "ba-bu", "han-gu-ku". En coreano se cierra la boca y se queda ahí.» Cierra la mano como un puño al terminar la sílaba: «밥. 따라 하세요: 밥.»
-Imagen sugerida: Edificio de tres pisos: consonante, vocal y 받침 en el piso de abajo
+Imagen: incluida (dibujo de la casa).
 Fuente: Adaptar Hangul_Deck_Cap3-4.pptx lám. 93 (el edificio de tres pisos)
 Lámina 5</a:t>
             </a:r>
@@ -3034,7 +3033,7 @@
             <a:r>
               <a:rPr lang="en-US" dirty="0"/>
               <a:t>≈ 1 min 30 s. «La más traicionera para nosotros: ㄴ o ㅇ al final.» Di «반 … 방. 안 … 앙» y pregunta «¿Cuál dije? 방… ¿ㄴ o ㅇ?»: responden con la mano (palma abierta = ㅇ, dedo arriba = ㄴ). Suma ㄹ final = l (물), ㄹㄹ = l larga (칠레) y ㅁ final con labios cerrados (김치, no "kinchi"). Con alumnos del Caribe, Centroamérica o partes de Perú, guíate por la lengua y no por la palabra "pan".
-Imagen sugerida: Dibujo de la lengua de perfil: adelante, tocando detrás de los dientes (ㄴ) / atrás, con la boca abierta (ㅇ)
+Imagen: incluida (dibujo de la casa).
 Fuente: Hangul_Deck_Cap3-4.pptx lám. 106 (nasales) como base
 Lámina 8</a:t>
             </a:r>
@@ -3124,7 +3123,7 @@
             <a:r>
               <a:rPr lang="en-US" dirty="0"/>
               <a:t>20:08–20:10, vista del orador y tira de papel. «Ya conocen ㄱ y ㅋ. Hoy llega la tercera hermana: ㄲ. Tomen su hoja y pónganla frente a la boca.» «카» (el papel se mueve: aspirada) · «까» (no se mueve: la garganta aprieta, como si dijeras la sílaba un poquito enojada) · «가» (suave, con muy poquito aire). Coro por filas: «가 카 까 · 다 타 따 · 바 파 빠 · 사 싸 · 자 차 짜. 따라 하세요.» Puente opcional (⚑, solo si te convence al oído): nuestra p, t, k casi no tiene aire, así que está más cerca de ㅃ, ㄸ, ㄲ que de ㅍ, ㅌ, ㅋ.
-Imagen sugerida: Dibujo de una tira de papel frente a la boca
+Imagen: incluida (dibujo de la casa).
 Fuente: Hangul_Deck_Cap3-4.pptx lám. 81 ("Aspiradas y dobles")
 Lámina 9</a:t>
             </a:r>
@@ -4198,7 +4197,7 @@
               <a:buNone/>
             </a:pPr>
             <a:r>
-              <a:rPr lang="en-US" sz="4400" b="1" dirty="0">
+              <a:rPr lang="en-US" sz="3600" b="1" dirty="0">
                 <a:solidFill>
                   <a:srgbClr val="FFFFFF"/>
                 </a:solidFill>
@@ -4372,7 +4371,7 @@
         <p:spPr>
           <a:xfrm>
             <a:off x="548640" y="1325880"/>
-            <a:ext cx="11064240" cy="457200"/>
+            <a:ext cx="11091672" cy="457200"/>
           </a:xfrm>
           <a:prstGeom prst="rect">
             <a:avLst/>
@@ -4466,7 +4465,7 @@
               <a:buNone/>
             </a:pPr>
             <a:r>
-              <a:rPr lang="ko-KR" altLang="en-US" sz="7600" b="1" dirty="0">
+              <a:rPr lang="ko-KR" altLang="en-US" sz="4500" b="1" dirty="0">
                 <a:solidFill>
                   <a:srgbClr val="4236F6"/>
                 </a:solidFill>
@@ -4476,7 +4475,7 @@
               </a:rPr>
               <a:t>ㅐ</a:t>
             </a:r>
-            <a:endParaRPr lang="en-US" sz="7600" dirty="0"/>
+            <a:endParaRPr lang="en-US" sz="4500" dirty="0"/>
           </a:p>
         </p:txBody>
       </p:sp>
@@ -4507,7 +4506,7 @@
               <a:buNone/>
             </a:pPr>
             <a:r>
-              <a:rPr lang="ko-KR" altLang="en-US" sz="1700" dirty="0">
+              <a:rPr lang="ko-KR" altLang="en-US" sz="1200" dirty="0">
                 <a:solidFill>
                   <a:srgbClr val="5C5F6B"/>
                 </a:solidFill>
@@ -4518,14 +4517,14 @@
               <a:t>"e" (hoy suena igual que ㅔ</a:t>
             </a:r>
             <a:r>
-              <a:rPr lang="en-US" sz="1700" dirty="0">
+              <a:rPr lang="en-US" sz="1200" dirty="0">
                 <a:solidFill>
                   <a:srgbClr val="5C5F6B"/>
                 </a:solidFill>
               </a:rPr>
               <a:t>)</a:t>
             </a:r>
-            <a:endParaRPr lang="en-US" sz="1700" dirty="0"/>
+            <a:endParaRPr lang="en-US" sz="1200" dirty="0"/>
           </a:p>
         </p:txBody>
       </p:sp>
@@ -4583,7 +4582,7 @@
               <a:buNone/>
             </a:pPr>
             <a:r>
-              <a:rPr lang="ko-KR" altLang="en-US" sz="7600" b="1" dirty="0">
+              <a:rPr lang="ko-KR" altLang="en-US" sz="4500" b="1" dirty="0">
                 <a:solidFill>
                   <a:srgbClr val="4236F6"/>
                 </a:solidFill>
@@ -4593,7 +4592,7 @@
               </a:rPr>
               <a:t>ㅔ</a:t>
             </a:r>
-            <a:endParaRPr lang="en-US" sz="7600" dirty="0"/>
+            <a:endParaRPr lang="en-US" sz="4500" dirty="0"/>
           </a:p>
         </p:txBody>
       </p:sp>
@@ -4624,14 +4623,14 @@
               <a:buNone/>
             </a:pPr>
             <a:r>
-              <a:rPr lang="en-US" sz="1700" dirty="0">
+              <a:rPr lang="en-US" sz="1200" dirty="0">
                 <a:solidFill>
                   <a:srgbClr val="5C5F6B"/>
                 </a:solidFill>
               </a:rPr>
               <a:t>"e"</a:t>
             </a:r>
-            <a:endParaRPr lang="en-US" sz="1700" dirty="0"/>
+            <a:endParaRPr lang="en-US" sz="1200" dirty="0"/>
           </a:p>
         </p:txBody>
       </p:sp>
@@ -4689,7 +4688,7 @@
               <a:buNone/>
             </a:pPr>
             <a:r>
-              <a:rPr lang="ko-KR" altLang="en-US" sz="7600" b="1" dirty="0">
+              <a:rPr lang="ko-KR" altLang="en-US" sz="4500" b="1" dirty="0">
                 <a:solidFill>
                   <a:srgbClr val="4236F6"/>
                 </a:solidFill>
@@ -4699,7 +4698,7 @@
               </a:rPr>
               <a:t>ㅖ</a:t>
             </a:r>
-            <a:endParaRPr lang="en-US" sz="7600" dirty="0"/>
+            <a:endParaRPr lang="en-US" sz="4500" dirty="0"/>
           </a:p>
         </p:txBody>
       </p:sp>
@@ -4730,14 +4729,14 @@
               <a:buNone/>
             </a:pPr>
             <a:r>
-              <a:rPr lang="en-US" sz="1700" dirty="0">
+              <a:rPr lang="en-US" sz="1200" dirty="0">
                 <a:solidFill>
                   <a:srgbClr val="5C5F6B"/>
                 </a:solidFill>
               </a:rPr>
               <a:t>"ye"</a:t>
             </a:r>
-            <a:endParaRPr lang="en-US" sz="1700" dirty="0"/>
+            <a:endParaRPr lang="en-US" sz="1200" dirty="0"/>
           </a:p>
         </p:txBody>
       </p:sp>
@@ -4795,7 +4794,7 @@
               <a:buNone/>
             </a:pPr>
             <a:r>
-              <a:rPr lang="ko-KR" altLang="en-US" sz="7600" b="1" dirty="0">
+              <a:rPr lang="ko-KR" altLang="en-US" sz="4500" b="1" dirty="0">
                 <a:solidFill>
                   <a:srgbClr val="4236F6"/>
                 </a:solidFill>
@@ -4805,7 +4804,7 @@
               </a:rPr>
               <a:t>ㅚ</a:t>
             </a:r>
-            <a:endParaRPr lang="en-US" sz="7600" dirty="0"/>
+            <a:endParaRPr lang="en-US" sz="4500" dirty="0"/>
           </a:p>
         </p:txBody>
       </p:sp>
@@ -4836,14 +4835,14 @@
               <a:buNone/>
             </a:pPr>
             <a:r>
-              <a:rPr lang="en-US" sz="1700" dirty="0">
+              <a:rPr lang="en-US" sz="1200" dirty="0">
                 <a:solidFill>
                   <a:srgbClr val="5C5F6B"/>
                 </a:solidFill>
               </a:rPr>
               <a:t>"we"</a:t>
             </a:r>
-            <a:endParaRPr lang="en-US" sz="1700" dirty="0"/>
+            <a:endParaRPr lang="en-US" sz="1200" dirty="0"/>
           </a:p>
         </p:txBody>
       </p:sp>
@@ -4901,7 +4900,7 @@
               <a:buNone/>
             </a:pPr>
             <a:r>
-              <a:rPr lang="ko-KR" altLang="en-US" sz="7600" b="1" dirty="0">
+              <a:rPr lang="ko-KR" altLang="en-US" sz="4500" b="1" dirty="0">
                 <a:solidFill>
                   <a:srgbClr val="4236F6"/>
                 </a:solidFill>
@@ -4911,7 +4910,7 @@
               </a:rPr>
               <a:t>ㅟ</a:t>
             </a:r>
-            <a:endParaRPr lang="en-US" sz="7600" dirty="0"/>
+            <a:endParaRPr lang="en-US" sz="4500" dirty="0"/>
           </a:p>
         </p:txBody>
       </p:sp>
@@ -4942,14 +4941,14 @@
               <a:buNone/>
             </a:pPr>
             <a:r>
-              <a:rPr lang="en-US" sz="1700" dirty="0">
+              <a:rPr lang="en-US" sz="1200" dirty="0">
                 <a:solidFill>
                   <a:srgbClr val="5C5F6B"/>
                 </a:solidFill>
               </a:rPr>
               <a:t>"wi"</a:t>
             </a:r>
-            <a:endParaRPr lang="en-US" sz="1700" dirty="0"/>
+            <a:endParaRPr lang="en-US" sz="1200" dirty="0"/>
           </a:p>
         </p:txBody>
       </p:sp>
@@ -5007,7 +5006,7 @@
               <a:buNone/>
             </a:pPr>
             <a:r>
-              <a:rPr lang="ko-KR" altLang="en-US" sz="7600" b="1" dirty="0">
+              <a:rPr lang="ko-KR" altLang="en-US" sz="4500" b="1" dirty="0">
                 <a:solidFill>
                   <a:srgbClr val="4236F6"/>
                 </a:solidFill>
@@ -5017,7 +5016,7 @@
               </a:rPr>
               <a:t>ㅘ</a:t>
             </a:r>
-            <a:endParaRPr lang="en-US" sz="7600" dirty="0"/>
+            <a:endParaRPr lang="en-US" sz="4500" dirty="0"/>
           </a:p>
         </p:txBody>
       </p:sp>
@@ -5048,14 +5047,14 @@
               <a:buNone/>
             </a:pPr>
             <a:r>
-              <a:rPr lang="en-US" sz="1700" dirty="0">
+              <a:rPr lang="en-US" sz="1200" dirty="0">
                 <a:solidFill>
                   <a:srgbClr val="5C5F6B"/>
                 </a:solidFill>
               </a:rPr>
               <a:t>"wa"</a:t>
             </a:r>
-            <a:endParaRPr lang="en-US" sz="1700" dirty="0"/>
+            <a:endParaRPr lang="en-US" sz="1200" dirty="0"/>
           </a:p>
         </p:txBody>
       </p:sp>
@@ -5113,7 +5112,7 @@
               <a:buNone/>
             </a:pPr>
             <a:r>
-              <a:rPr lang="ko-KR" altLang="en-US" sz="7600" b="1" dirty="0">
+              <a:rPr lang="ko-KR" altLang="en-US" sz="4500" b="1" dirty="0">
                 <a:solidFill>
                   <a:srgbClr val="4236F6"/>
                 </a:solidFill>
@@ -5123,7 +5122,7 @@
               </a:rPr>
               <a:t>ㅝ</a:t>
             </a:r>
-            <a:endParaRPr lang="en-US" sz="7600" dirty="0"/>
+            <a:endParaRPr lang="en-US" sz="4500" dirty="0"/>
           </a:p>
         </p:txBody>
       </p:sp>
@@ -5154,14 +5153,14 @@
               <a:buNone/>
             </a:pPr>
             <a:r>
-              <a:rPr lang="en-US" sz="1700" dirty="0">
+              <a:rPr lang="en-US" sz="1200" dirty="0">
                 <a:solidFill>
                   <a:srgbClr val="5C5F6B"/>
                 </a:solidFill>
               </a:rPr>
               <a:t>"wo"</a:t>
             </a:r>
-            <a:endParaRPr lang="en-US" sz="1700" dirty="0"/>
+            <a:endParaRPr lang="en-US" sz="1200" dirty="0"/>
           </a:p>
         </p:txBody>
       </p:sp>
@@ -5219,7 +5218,7 @@
               <a:buNone/>
             </a:pPr>
             <a:r>
-              <a:rPr lang="ko-KR" altLang="en-US" sz="7600" b="1" dirty="0">
+              <a:rPr lang="ko-KR" altLang="en-US" sz="4500" b="1" dirty="0">
                 <a:solidFill>
                   <a:srgbClr val="4236F6"/>
                 </a:solidFill>
@@ -5229,7 +5228,7 @@
               </a:rPr>
               <a:t>ㅢ</a:t>
             </a:r>
-            <a:endParaRPr lang="en-US" sz="7600" dirty="0"/>
+            <a:endParaRPr lang="en-US" sz="4500" dirty="0"/>
           </a:p>
         </p:txBody>
       </p:sp>
@@ -5260,14 +5259,14 @@
               <a:buNone/>
             </a:pPr>
             <a:r>
-              <a:rPr lang="en-US" sz="1700" dirty="0">
+              <a:rPr lang="en-US" sz="1200" dirty="0">
                 <a:solidFill>
                   <a:srgbClr val="5C5F6B"/>
                 </a:solidFill>
               </a:rPr>
               <a:t>"ui"</a:t>
             </a:r>
-            <a:endParaRPr lang="en-US" sz="1700" dirty="0"/>
+            <a:endParaRPr lang="en-US" sz="1200" dirty="0"/>
           </a:p>
         </p:txBody>
       </p:sp>
@@ -5404,7 +5403,7 @@
               <a:buNone/>
             </a:pPr>
             <a:r>
-              <a:rPr lang="ko-KR" altLang="en-US" sz="1700" dirty="0">
+              <a:rPr lang="ko-KR" altLang="en-US" sz="1200" dirty="0">
                 <a:solidFill>
                   <a:srgbClr val="5C5F6B"/>
                 </a:solidFill>
@@ -5415,14 +5414,14 @@
               <a:t>ㅖ </a:t>
             </a:r>
             <a:r>
-              <a:rPr lang="en-US" sz="1700" dirty="0">
+              <a:rPr lang="en-US" sz="1200" dirty="0">
                 <a:solidFill>
                   <a:srgbClr val="5C5F6B"/>
                 </a:solidFill>
               </a:rPr>
               <a:t>· reloj</a:t>
             </a:r>
-            <a:endParaRPr lang="en-US" sz="1700" dirty="0"/>
+            <a:endParaRPr lang="en-US" sz="1200" dirty="0"/>
           </a:p>
         </p:txBody>
       </p:sp>
@@ -5559,7 +5558,7 @@
               <a:buNone/>
             </a:pPr>
             <a:r>
-              <a:rPr lang="ko-KR" altLang="en-US" sz="1700" dirty="0">
+              <a:rPr lang="ko-KR" altLang="en-US" sz="1200" dirty="0">
                 <a:solidFill>
                   <a:srgbClr val="5C5F6B"/>
                 </a:solidFill>
@@ -5570,14 +5569,14 @@
               <a:t>ㅚ </a:t>
             </a:r>
             <a:r>
-              <a:rPr lang="en-US" sz="1700" dirty="0">
+              <a:rPr lang="en-US" sz="1200" dirty="0">
                 <a:solidFill>
                   <a:srgbClr val="5C5F6B"/>
                 </a:solidFill>
               </a:rPr>
               <a:t>· empresa</a:t>
             </a:r>
-            <a:endParaRPr lang="en-US" sz="1700" dirty="0"/>
+            <a:endParaRPr lang="en-US" sz="1200" dirty="0"/>
           </a:p>
         </p:txBody>
       </p:sp>
@@ -5635,7 +5634,7 @@
               <a:buNone/>
             </a:pPr>
             <a:r>
-              <a:rPr lang="ko-KR" altLang="en-US" sz="7600" b="1" dirty="0">
+              <a:rPr lang="ko-KR" altLang="en-US" sz="4500" b="1" dirty="0">
                 <a:solidFill>
                   <a:srgbClr val="4236F6"/>
                 </a:solidFill>
@@ -5645,7 +5644,7 @@
               </a:rPr>
               <a:t>위</a:t>
             </a:r>
-            <a:endParaRPr lang="en-US" sz="7600" dirty="0"/>
+            <a:endParaRPr lang="en-US" sz="4500" dirty="0"/>
           </a:p>
         </p:txBody>
       </p:sp>
@@ -5714,7 +5713,7 @@
               <a:buNone/>
             </a:pPr>
             <a:r>
-              <a:rPr lang="ko-KR" altLang="en-US" sz="1700" dirty="0">
+              <a:rPr lang="ko-KR" altLang="en-US" sz="1200" dirty="0">
                 <a:solidFill>
                   <a:srgbClr val="5C5F6B"/>
                 </a:solidFill>
@@ -5725,14 +5724,14 @@
               <a:t>ㅟ </a:t>
             </a:r>
             <a:r>
-              <a:rPr lang="en-US" sz="1700" dirty="0">
+              <a:rPr lang="en-US" sz="1200" dirty="0">
                 <a:solidFill>
                   <a:srgbClr val="5C5F6B"/>
                 </a:solidFill>
               </a:rPr>
               <a:t>· arriba</a:t>
             </a:r>
-            <a:endParaRPr lang="en-US" sz="1700" dirty="0"/>
+            <a:endParaRPr lang="en-US" sz="1200" dirty="0"/>
           </a:p>
         </p:txBody>
       </p:sp>
@@ -5869,7 +5868,7 @@
               <a:buNone/>
             </a:pPr>
             <a:r>
-              <a:rPr lang="ko-KR" altLang="en-US" sz="1700" dirty="0">
+              <a:rPr lang="ko-KR" altLang="en-US" sz="1200" dirty="0">
                 <a:solidFill>
                   <a:srgbClr val="5C5F6B"/>
                 </a:solidFill>
@@ -5880,14 +5879,14 @@
               <a:t>ㅢ </a:t>
             </a:r>
             <a:r>
-              <a:rPr lang="en-US" sz="1700" dirty="0">
+              <a:rPr lang="en-US" sz="1200" dirty="0">
                 <a:solidFill>
                   <a:srgbClr val="5C5F6B"/>
                 </a:solidFill>
               </a:rPr>
               <a:t>· silla</a:t>
             </a:r>
-            <a:endParaRPr lang="en-US" sz="1700" dirty="0"/>
+            <a:endParaRPr lang="en-US" sz="1200" dirty="0"/>
           </a:p>
         </p:txBody>
       </p:sp>
@@ -6024,7 +6023,7 @@
               <a:buNone/>
             </a:pPr>
             <a:r>
-              <a:rPr lang="ko-KR" altLang="en-US" sz="1700" dirty="0">
+              <a:rPr lang="ko-KR" altLang="en-US" sz="1200" dirty="0">
                 <a:solidFill>
                   <a:srgbClr val="5C5F6B"/>
                 </a:solidFill>
@@ -6035,14 +6034,14 @@
               <a:t>ㅢ </a:t>
             </a:r>
             <a:r>
-              <a:rPr lang="en-US" sz="1700" dirty="0">
+              <a:rPr lang="en-US" sz="1200" dirty="0">
                 <a:solidFill>
                   <a:srgbClr val="5C5F6B"/>
                 </a:solidFill>
               </a:rPr>
               <a:t>· médico, médica</a:t>
             </a:r>
-            <a:endParaRPr lang="en-US" sz="1700" dirty="0"/>
+            <a:endParaRPr lang="en-US" sz="1200" dirty="0"/>
           </a:p>
         </p:txBody>
       </p:sp>
@@ -6100,7 +6099,7 @@
               <a:buNone/>
             </a:pPr>
             <a:r>
-              <a:rPr lang="ko-KR" altLang="en-US" sz="7600" b="1" dirty="0">
+              <a:rPr lang="ko-KR" altLang="en-US" sz="4500" b="1" dirty="0">
                 <a:solidFill>
                   <a:srgbClr val="4236F6"/>
                 </a:solidFill>
@@ -6110,7 +6109,7 @@
               </a:rPr>
               <a:t>뭐</a:t>
             </a:r>
-            <a:endParaRPr lang="en-US" sz="7600" dirty="0"/>
+            <a:endParaRPr lang="en-US" sz="4500" dirty="0"/>
           </a:p>
         </p:txBody>
       </p:sp>
@@ -6179,7 +6178,7 @@
               <a:buNone/>
             </a:pPr>
             <a:r>
-              <a:rPr lang="ko-KR" altLang="en-US" sz="1700" dirty="0">
+              <a:rPr lang="ko-KR" altLang="en-US" sz="1200" dirty="0">
                 <a:solidFill>
                   <a:srgbClr val="5C5F6B"/>
                 </a:solidFill>
@@ -6190,14 +6189,14 @@
               <a:t>ㅝ </a:t>
             </a:r>
             <a:r>
-              <a:rPr lang="en-US" sz="1700" dirty="0">
+              <a:rPr lang="en-US" sz="1200" dirty="0">
                 <a:solidFill>
                   <a:srgbClr val="5C5F6B"/>
                 </a:solidFill>
               </a:rPr>
               <a:t>· qué</a:t>
             </a:r>
-            <a:endParaRPr lang="en-US" sz="1700" dirty="0"/>
+            <a:endParaRPr lang="en-US" sz="1200" dirty="0"/>
           </a:p>
         </p:txBody>
       </p:sp>
@@ -6560,7 +6559,7 @@
         <p:spPr>
           <a:xfrm>
             <a:off x="548640" y="1325880"/>
-            <a:ext cx="11064240" cy="457200"/>
+            <a:ext cx="11091672" cy="457200"/>
           </a:xfrm>
           <a:prstGeom prst="rect">
             <a:avLst/>
@@ -6598,7 +6597,7 @@
           <p:nvPr>
             <p:extLst>
               <p:ext uri="{D42A27DB-BD31-4B8C-83A1-F6EECF244321}">
-                <p14:modId xmlns:p14="http://schemas.microsoft.com/office/powerpoint/2010/main" val="4096556133"/>
+                <p14:modId xmlns:p14="http://schemas.microsoft.com/office/powerpoint/2010/main" val="4277100514"/>
               </p:ext>
             </p:extLst>
           </p:nvPr>
@@ -7961,7 +7960,7 @@
           <p:nvPr>
             <p:extLst>
               <p:ext uri="{D42A27DB-BD31-4B8C-83A1-F6EECF244321}">
-                <p14:modId xmlns:p14="http://schemas.microsoft.com/office/powerpoint/2010/main" val="2178669702"/>
+                <p14:modId xmlns:p14="http://schemas.microsoft.com/office/powerpoint/2010/main" val="1942923689"/>
               </p:ext>
             </p:extLst>
           </p:nvPr>
@@ -9464,7 +9463,7 @@
               <a:buChar char="•"/>
             </a:pPr>
             <a:r>
-              <a:rPr lang="ko-KR" altLang="en-US" sz="2400" dirty="0">
+              <a:rPr lang="ko-KR" altLang="en-US" sz="2800" dirty="0">
                 <a:solidFill>
                   <a:srgbClr val="14142B"/>
                 </a:solidFill>
@@ -9475,14 +9474,14 @@
               <a:t>저는 기란이에요</a:t>
             </a:r>
             <a:r>
-              <a:rPr lang="en-US" sz="2400" dirty="0">
+              <a:rPr lang="en-US" sz="2800" dirty="0">
                 <a:solidFill>
                   <a:srgbClr val="14142B"/>
                 </a:solidFill>
               </a:rPr>
               <a:t>. — Soy Kiran.</a:t>
             </a:r>
-            <a:endParaRPr lang="en-US" sz="2400" dirty="0"/>
+            <a:endParaRPr lang="en-US" sz="2800" dirty="0"/>
           </a:p>
           <a:p>
             <a:pPr marL="228600" indent="-228600" eaLnBrk="1">
@@ -9493,7 +9492,7 @@
               <a:buChar char="•"/>
             </a:pPr>
             <a:r>
-              <a:rPr lang="ko-KR" altLang="en-US" sz="2400" dirty="0">
+              <a:rPr lang="ko-KR" altLang="en-US" sz="2800" dirty="0">
                 <a:solidFill>
                   <a:srgbClr val="14142B"/>
                 </a:solidFill>
@@ -9504,14 +9503,14 @@
               <a:t>한국 사람이에요</a:t>
             </a:r>
             <a:r>
-              <a:rPr lang="en-US" sz="2400" dirty="0">
+              <a:rPr lang="en-US" sz="2800" dirty="0">
                 <a:solidFill>
                   <a:srgbClr val="14142B"/>
                 </a:solidFill>
               </a:rPr>
               <a:t>. — Soy coreana.</a:t>
             </a:r>
-            <a:endParaRPr lang="en-US" sz="2400" dirty="0"/>
+            <a:endParaRPr lang="en-US" sz="2800" dirty="0"/>
           </a:p>
           <a:p>
             <a:pPr marL="228600" indent="-228600" eaLnBrk="1">
@@ -9522,7 +9521,7 @@
               <a:buChar char="•"/>
             </a:pPr>
             <a:r>
-              <a:rPr lang="ko-KR" altLang="en-US" sz="2400" dirty="0">
+              <a:rPr lang="ko-KR" altLang="en-US" sz="2800" dirty="0">
                 <a:solidFill>
                   <a:srgbClr val="14142B"/>
                 </a:solidFill>
@@ -9533,14 +9532,14 @@
               <a:t>선생님이에요</a:t>
             </a:r>
             <a:r>
-              <a:rPr lang="en-US" sz="2400" dirty="0">
+              <a:rPr lang="en-US" sz="2800" dirty="0">
                 <a:solidFill>
                   <a:srgbClr val="14142B"/>
                 </a:solidFill>
               </a:rPr>
               <a:t>. — Soy profesora.</a:t>
             </a:r>
-            <a:endParaRPr lang="en-US" sz="2400" dirty="0"/>
+            <a:endParaRPr lang="en-US" sz="2800" dirty="0"/>
           </a:p>
         </p:txBody>
       </p:sp>
@@ -10486,7 +10485,7 @@
         <p:spPr>
           <a:xfrm>
             <a:off x="548640" y="1325880"/>
-            <a:ext cx="11064240" cy="457200"/>
+            <a:ext cx="11091672" cy="457200"/>
           </a:xfrm>
           <a:prstGeom prst="rect">
             <a:avLst/>
@@ -11056,7 +11055,7 @@
           <p:nvPr>
             <p:extLst>
               <p:ext uri="{D42A27DB-BD31-4B8C-83A1-F6EECF244321}">
-                <p14:modId xmlns:p14="http://schemas.microsoft.com/office/powerpoint/2010/main" val="1621083838"/>
+                <p14:modId xmlns:p14="http://schemas.microsoft.com/office/powerpoint/2010/main" val="3979425834"/>
               </p:ext>
             </p:extLst>
           </p:nvPr>
@@ -13914,7 +13913,7 @@
         <p:spPr>
           <a:xfrm>
             <a:off x="548640" y="1325880"/>
-            <a:ext cx="11064240" cy="457200"/>
+            <a:ext cx="11091672" cy="457200"/>
           </a:xfrm>
           <a:prstGeom prst="rect">
             <a:avLst/>
@@ -14001,7 +14000,7 @@
       </p:sp>
       <p:pic>
         <p:nvPicPr>
-          <p:cNvPr id="5" name="dibujo_0" descr="C:\Users\Chingu\AppData\Local\Temp\claude\C--Users-Chingu-Desktop-ACADEMIASEULWEB\d4111e1b-5523-44ea-97b2-b1a1d9545b9e\scratchpad\decks\cache\ecb9a0eba088.png"/>
+          <p:cNvPr id="5" name="dibujo_0" descr="C:\Users\Chingu\AppData\Local\Temp\claude\C--Users-Chingu-Desktop-ACADEMIASEULWEB\d4111e1b-5523-44ea-97b2-b1a1d9545b9e\scratchpad\decks\cache\img_0257b11da8023876.png"/>
           <p:cNvPicPr>
             <a:picLocks noChangeAspect="1"/>
           </p:cNvPicPr>
@@ -14015,8 +14014,8 @@
         </p:blipFill>
         <p:spPr>
           <a:xfrm>
-            <a:off x="1422121" y="1984248"/>
-            <a:ext cx="854507" cy="854507"/>
+            <a:off x="1361084" y="1984248"/>
+            <a:ext cx="976579" cy="976579"/>
           </a:xfrm>
           <a:prstGeom prst="rect">
             <a:avLst/>
@@ -14031,8 +14030,8 @@
         </p:nvSpPr>
         <p:spPr>
           <a:xfrm>
-            <a:off x="548640" y="2857043"/>
-            <a:ext cx="2601468" cy="447599"/>
+            <a:off x="548640" y="2979115"/>
+            <a:ext cx="2601468" cy="406908"/>
           </a:xfrm>
           <a:prstGeom prst="rect">
             <a:avLst/>
@@ -14050,7 +14049,7 @@
               <a:buNone/>
             </a:pPr>
             <a:r>
-              <a:rPr lang="ko-KR" altLang="en-US" sz="2800" b="1" dirty="0">
+              <a:rPr lang="ko-KR" altLang="en-US" sz="2500" b="1" dirty="0">
                 <a:solidFill>
                   <a:srgbClr val="4236F6"/>
                 </a:solidFill>
@@ -14060,7 +14059,7 @@
               </a:rPr>
               <a:t>칠레</a:t>
             </a:r>
-            <a:endParaRPr lang="en-US" sz="2800" dirty="0"/>
+            <a:endParaRPr lang="en-US" sz="2500" dirty="0"/>
           </a:p>
         </p:txBody>
       </p:sp>
@@ -14072,7 +14071,7 @@
         </p:nvSpPr>
         <p:spPr>
           <a:xfrm>
-            <a:off x="548640" y="3304642"/>
+            <a:off x="548640" y="3386023"/>
             <a:ext cx="2601468" cy="274320"/>
           </a:xfrm>
           <a:prstGeom prst="rect">
@@ -14110,7 +14109,7 @@
         </p:nvSpPr>
         <p:spPr>
           <a:xfrm>
-            <a:off x="621792" y="3578962"/>
+            <a:off x="621792" y="3660343"/>
             <a:ext cx="2455164" cy="274320"/>
           </a:xfrm>
           <a:prstGeom prst="rect">
@@ -14165,8 +14164,8 @@
         </p:blipFill>
         <p:spPr>
           <a:xfrm>
-            <a:off x="2711196" y="3488436"/>
-            <a:ext cx="329184" cy="329184"/>
+            <a:off x="2747772" y="1947672"/>
+            <a:ext cx="310896" cy="310896"/>
           </a:xfrm>
           <a:prstGeom prst="rect">
             <a:avLst/>
@@ -14209,7 +14208,7 @@
       </p:sp>
       <p:pic>
         <p:nvPicPr>
-          <p:cNvPr id="11" name="dibujo_1" descr="C:\Users\Chingu\AppData\Local\Temp\claude\C--Users-Chingu-Desktop-ACADEMIASEULWEB\d4111e1b-5523-44ea-97b2-b1a1d9545b9e\scratchpad\decks\cache\eba995ec8b9cecbd94.png"/>
+          <p:cNvPr id="11" name="dibujo_1" descr="C:\Users\Chingu\AppData\Local\Temp\claude\C--Users-Chingu-Desktop-ACADEMIASEULWEB\d4111e1b-5523-44ea-97b2-b1a1d9545b9e\scratchpad\decks\cache\img_2280de5d4e6335c7.png"/>
           <p:cNvPicPr>
             <a:picLocks noChangeAspect="1"/>
           </p:cNvPicPr>
@@ -14223,8 +14222,8 @@
         </p:blipFill>
         <p:spPr>
           <a:xfrm>
-            <a:off x="4252189" y="1984248"/>
-            <a:ext cx="854507" cy="854507"/>
+            <a:off x="4191152" y="1984248"/>
+            <a:ext cx="976579" cy="976579"/>
           </a:xfrm>
           <a:prstGeom prst="rect">
             <a:avLst/>
@@ -14239,8 +14238,8 @@
         </p:nvSpPr>
         <p:spPr>
           <a:xfrm>
-            <a:off x="3378708" y="2857043"/>
-            <a:ext cx="2601468" cy="447599"/>
+            <a:off x="3378708" y="2979115"/>
+            <a:ext cx="2601468" cy="406908"/>
           </a:xfrm>
           <a:prstGeom prst="rect">
             <a:avLst/>
@@ -14258,7 +14257,7 @@
               <a:buNone/>
             </a:pPr>
             <a:r>
-              <a:rPr lang="ko-KR" altLang="en-US" sz="2800" b="1" dirty="0">
+              <a:rPr lang="ko-KR" altLang="en-US" sz="2500" b="1" dirty="0">
                 <a:solidFill>
                   <a:srgbClr val="4236F6"/>
                 </a:solidFill>
@@ -14268,7 +14267,7 @@
               </a:rPr>
               <a:t>멕시코</a:t>
             </a:r>
-            <a:endParaRPr lang="en-US" sz="2800" dirty="0"/>
+            <a:endParaRPr lang="en-US" sz="2500" dirty="0"/>
           </a:p>
         </p:txBody>
       </p:sp>
@@ -14280,7 +14279,7 @@
         </p:nvSpPr>
         <p:spPr>
           <a:xfrm>
-            <a:off x="3378708" y="3304642"/>
+            <a:off x="3378708" y="3386023"/>
             <a:ext cx="2601468" cy="274320"/>
           </a:xfrm>
           <a:prstGeom prst="rect">
@@ -14318,7 +14317,7 @@
         </p:nvSpPr>
         <p:spPr>
           <a:xfrm>
-            <a:off x="3451860" y="3578962"/>
+            <a:off x="3451860" y="3660343"/>
             <a:ext cx="2455164" cy="274320"/>
           </a:xfrm>
           <a:prstGeom prst="rect">
@@ -14373,8 +14372,8 @@
         </p:blipFill>
         <p:spPr>
           <a:xfrm>
-            <a:off x="5541264" y="3488436"/>
-            <a:ext cx="329184" cy="329184"/>
+            <a:off x="5577840" y="1947672"/>
+            <a:ext cx="310896" cy="310896"/>
           </a:xfrm>
           <a:prstGeom prst="rect">
             <a:avLst/>
@@ -14417,7 +14416,7 @@
       </p:sp>
       <p:pic>
         <p:nvPicPr>
-          <p:cNvPr id="17" name="dibujo_2" descr="C:\Users\Chingu\AppData\Local\Temp\claude\C--Users-Chingu-Desktop-ACADEMIASEULWEB\d4111e1b-5523-44ea-97b2-b1a1d9545b9e\scratchpad\decks\cache\ecbd9ceba1acebb984ec9584.png"/>
+          <p:cNvPr id="17" name="dibujo_2" descr="C:\Users\Chingu\AppData\Local\Temp\claude\C--Users-Chingu-Desktop-ACADEMIASEULWEB\d4111e1b-5523-44ea-97b2-b1a1d9545b9e\scratchpad\decks\cache\img_954d2a74e8bb7d69.png"/>
           <p:cNvPicPr>
             <a:picLocks noChangeAspect="1"/>
           </p:cNvPicPr>
@@ -14431,8 +14430,8 @@
         </p:blipFill>
         <p:spPr>
           <a:xfrm>
-            <a:off x="7082257" y="1984248"/>
-            <a:ext cx="854507" cy="854507"/>
+            <a:off x="7021220" y="1984248"/>
+            <a:ext cx="976579" cy="976579"/>
           </a:xfrm>
           <a:prstGeom prst="rect">
             <a:avLst/>
@@ -14447,8 +14446,8 @@
         </p:nvSpPr>
         <p:spPr>
           <a:xfrm>
-            <a:off x="6208776" y="2857043"/>
-            <a:ext cx="2601468" cy="447599"/>
+            <a:off x="6208776" y="2979115"/>
+            <a:ext cx="2601468" cy="406908"/>
           </a:xfrm>
           <a:prstGeom prst="rect">
             <a:avLst/>
@@ -14466,7 +14465,7 @@
               <a:buNone/>
             </a:pPr>
             <a:r>
-              <a:rPr lang="ko-KR" altLang="en-US" sz="2800" b="1" dirty="0">
+              <a:rPr lang="ko-KR" altLang="en-US" sz="2500" b="1" dirty="0">
                 <a:solidFill>
                   <a:srgbClr val="4236F6"/>
                 </a:solidFill>
@@ -14476,7 +14475,7 @@
               </a:rPr>
               <a:t>콜롬비아</a:t>
             </a:r>
-            <a:endParaRPr lang="en-US" sz="2800" dirty="0"/>
+            <a:endParaRPr lang="en-US" sz="2500" dirty="0"/>
           </a:p>
         </p:txBody>
       </p:sp>
@@ -14488,7 +14487,7 @@
         </p:nvSpPr>
         <p:spPr>
           <a:xfrm>
-            <a:off x="6208776" y="3304642"/>
+            <a:off x="6208776" y="3386023"/>
             <a:ext cx="2601468" cy="274320"/>
           </a:xfrm>
           <a:prstGeom prst="rect">
@@ -14526,7 +14525,7 @@
         </p:nvSpPr>
         <p:spPr>
           <a:xfrm>
-            <a:off x="6281928" y="3578962"/>
+            <a:off x="6281928" y="3660343"/>
             <a:ext cx="2455164" cy="274320"/>
           </a:xfrm>
           <a:prstGeom prst="rect">
@@ -14581,8 +14580,8 @@
         </p:blipFill>
         <p:spPr>
           <a:xfrm>
-            <a:off x="8371332" y="3488436"/>
-            <a:ext cx="329184" cy="329184"/>
+            <a:off x="8407908" y="1947672"/>
+            <a:ext cx="310896" cy="310896"/>
           </a:xfrm>
           <a:prstGeom prst="rect">
             <a:avLst/>
@@ -14625,7 +14624,7 @@
       </p:sp>
       <p:pic>
         <p:nvPicPr>
-          <p:cNvPr id="23" name="dibujo_3" descr="C:\Users\Chingu\AppData\Local\Temp\claude\C--Users-Chingu-Desktop-ACADEMIASEULWEB\d4111e1b-5523-44ea-97b2-b1a1d9545b9e\scratchpad\decks\cache\ed959ceab5ad.png"/>
+          <p:cNvPr id="23" name="dibujo_3" descr="C:\Users\Chingu\AppData\Local\Temp\claude\C--Users-Chingu-Desktop-ACADEMIASEULWEB\d4111e1b-5523-44ea-97b2-b1a1d9545b9e\scratchpad\decks\cache\img_a587f50a4a667ec7.png"/>
           <p:cNvPicPr>
             <a:picLocks noChangeAspect="1"/>
           </p:cNvPicPr>
@@ -14639,8 +14638,8 @@
         </p:blipFill>
         <p:spPr>
           <a:xfrm>
-            <a:off x="9912325" y="1984248"/>
-            <a:ext cx="854507" cy="854507"/>
+            <a:off x="9851288" y="1984248"/>
+            <a:ext cx="976579" cy="976579"/>
           </a:xfrm>
           <a:prstGeom prst="rect">
             <a:avLst/>
@@ -14655,8 +14654,8 @@
         </p:nvSpPr>
         <p:spPr>
           <a:xfrm>
-            <a:off x="9038844" y="2857043"/>
-            <a:ext cx="2601468" cy="447599"/>
+            <a:off x="9038844" y="2979115"/>
+            <a:ext cx="2601468" cy="406908"/>
           </a:xfrm>
           <a:prstGeom prst="rect">
             <a:avLst/>
@@ -14674,7 +14673,7 @@
               <a:buNone/>
             </a:pPr>
             <a:r>
-              <a:rPr lang="ko-KR" altLang="en-US" sz="2800" b="1" dirty="0">
+              <a:rPr lang="ko-KR" altLang="en-US" sz="2500" b="1" dirty="0">
                 <a:solidFill>
                   <a:srgbClr val="4236F6"/>
                 </a:solidFill>
@@ -14684,7 +14683,7 @@
               </a:rPr>
               <a:t>한국</a:t>
             </a:r>
-            <a:endParaRPr lang="en-US" sz="2800" dirty="0"/>
+            <a:endParaRPr lang="en-US" sz="2500" dirty="0"/>
           </a:p>
         </p:txBody>
       </p:sp>
@@ -14696,7 +14695,7 @@
         </p:nvSpPr>
         <p:spPr>
           <a:xfrm>
-            <a:off x="9038844" y="3304642"/>
+            <a:off x="9038844" y="3386023"/>
             <a:ext cx="2601468" cy="274320"/>
           </a:xfrm>
           <a:prstGeom prst="rect">
@@ -14734,7 +14733,7 @@
         </p:nvSpPr>
         <p:spPr>
           <a:xfrm>
-            <a:off x="9111996" y="3578962"/>
+            <a:off x="9111996" y="3660343"/>
             <a:ext cx="2455164" cy="274320"/>
           </a:xfrm>
           <a:prstGeom prst="rect">
@@ -14789,8 +14788,8 @@
         </p:blipFill>
         <p:spPr>
           <a:xfrm>
-            <a:off x="11201400" y="3488436"/>
-            <a:ext cx="329184" cy="329184"/>
+            <a:off x="11237976" y="1947672"/>
+            <a:ext cx="310896" cy="310896"/>
           </a:xfrm>
           <a:prstGeom prst="rect">
             <a:avLst/>
@@ -14833,7 +14832,7 @@
       </p:sp>
       <p:pic>
         <p:nvPicPr>
-          <p:cNvPr id="29" name="dibujo_4" descr="C:\Users\Chingu\AppData\Local\Temp\claude\C--Users-Chingu-Desktop-ACADEMIASEULWEB\d4111e1b-5523-44ea-97b2-b1a1d9545b9e\scratchpad\decks\cache\ec9584eba5b4ed97a8ed8bb0eb8298.png"/>
+          <p:cNvPr id="29" name="dibujo_4" descr="C:\Users\Chingu\AppData\Local\Temp\claude\C--Users-Chingu-Desktop-ACADEMIASEULWEB\d4111e1b-5523-44ea-97b2-b1a1d9545b9e\scratchpad\decks\cache\img_1519015e4ef4b038.png"/>
           <p:cNvPicPr>
             <a:picLocks noChangeAspect="1"/>
           </p:cNvPicPr>
@@ -14847,8 +14846,8 @@
         </p:blipFill>
         <p:spPr>
           <a:xfrm>
-            <a:off x="1422121" y="4247388"/>
-            <a:ext cx="854507" cy="854507"/>
+            <a:off x="1361084" y="4247388"/>
+            <a:ext cx="976579" cy="976579"/>
           </a:xfrm>
           <a:prstGeom prst="rect">
             <a:avLst/>
@@ -14863,8 +14862,8 @@
         </p:nvSpPr>
         <p:spPr>
           <a:xfrm>
-            <a:off x="548640" y="5120183"/>
-            <a:ext cx="2601468" cy="447599"/>
+            <a:off x="548640" y="5242255"/>
+            <a:ext cx="2601468" cy="406908"/>
           </a:xfrm>
           <a:prstGeom prst="rect">
             <a:avLst/>
@@ -14882,7 +14881,7 @@
               <a:buNone/>
             </a:pPr>
             <a:r>
-              <a:rPr lang="ko-KR" altLang="en-US" sz="2800" b="1" dirty="0">
+              <a:rPr lang="ko-KR" altLang="en-US" sz="2500" b="1" dirty="0">
                 <a:solidFill>
                   <a:srgbClr val="4236F6"/>
                 </a:solidFill>
@@ -14892,7 +14891,7 @@
               </a:rPr>
               <a:t>아르헨티나</a:t>
             </a:r>
-            <a:endParaRPr lang="en-US" sz="2800" dirty="0"/>
+            <a:endParaRPr lang="en-US" sz="2500" dirty="0"/>
           </a:p>
         </p:txBody>
       </p:sp>
@@ -14904,7 +14903,7 @@
         </p:nvSpPr>
         <p:spPr>
           <a:xfrm>
-            <a:off x="548640" y="5567782"/>
+            <a:off x="548640" y="5649163"/>
             <a:ext cx="2601468" cy="274320"/>
           </a:xfrm>
           <a:prstGeom prst="rect">
@@ -14942,7 +14941,7 @@
         </p:nvSpPr>
         <p:spPr>
           <a:xfrm>
-            <a:off x="621792" y="5842102"/>
+            <a:off x="621792" y="5923483"/>
             <a:ext cx="2455164" cy="274320"/>
           </a:xfrm>
           <a:prstGeom prst="rect">
@@ -14997,8 +14996,8 @@
         </p:blipFill>
         <p:spPr>
           <a:xfrm>
-            <a:off x="2711196" y="5751576"/>
-            <a:ext cx="329184" cy="329184"/>
+            <a:off x="2747772" y="4210812"/>
+            <a:ext cx="310896" cy="310896"/>
           </a:xfrm>
           <a:prstGeom prst="rect">
             <a:avLst/>
@@ -15041,7 +15040,7 @@
       </p:sp>
       <p:pic>
         <p:nvPicPr>
-          <p:cNvPr id="35" name="dibujo_5" descr="C:\Users\Chingu\AppData\Local\Temp\claude\C--Users-Chingu-Desktop-ACADEMIASEULWEB\d4111e1b-5523-44ea-97b2-b1a1d9545b9e\scratchpad\decks\cache\ed8e98eba3a8.png"/>
+          <p:cNvPr id="35" name="dibujo_5" descr="C:\Users\Chingu\AppData\Local\Temp\claude\C--Users-Chingu-Desktop-ACADEMIASEULWEB\d4111e1b-5523-44ea-97b2-b1a1d9545b9e\scratchpad\decks\cache\img_18173ee7621eb7f3.png"/>
           <p:cNvPicPr>
             <a:picLocks noChangeAspect="1"/>
           </p:cNvPicPr>
@@ -15055,8 +15054,8 @@
         </p:blipFill>
         <p:spPr>
           <a:xfrm>
-            <a:off x="4252189" y="4247388"/>
-            <a:ext cx="854507" cy="854507"/>
+            <a:off x="4191152" y="4247388"/>
+            <a:ext cx="976579" cy="976579"/>
           </a:xfrm>
           <a:prstGeom prst="rect">
             <a:avLst/>
@@ -15071,8 +15070,8 @@
         </p:nvSpPr>
         <p:spPr>
           <a:xfrm>
-            <a:off x="3378708" y="5120183"/>
-            <a:ext cx="2601468" cy="447599"/>
+            <a:off x="3378708" y="5242255"/>
+            <a:ext cx="2601468" cy="406908"/>
           </a:xfrm>
           <a:prstGeom prst="rect">
             <a:avLst/>
@@ -15090,7 +15089,7 @@
               <a:buNone/>
             </a:pPr>
             <a:r>
-              <a:rPr lang="ko-KR" altLang="en-US" sz="2800" b="1" dirty="0">
+              <a:rPr lang="ko-KR" altLang="en-US" sz="2500" b="1" dirty="0">
                 <a:solidFill>
                   <a:srgbClr val="4236F6"/>
                 </a:solidFill>
@@ -15100,7 +15099,7 @@
               </a:rPr>
               <a:t>페루</a:t>
             </a:r>
-            <a:endParaRPr lang="en-US" sz="2800" dirty="0"/>
+            <a:endParaRPr lang="en-US" sz="2500" dirty="0"/>
           </a:p>
         </p:txBody>
       </p:sp>
@@ -15112,7 +15111,7 @@
         </p:nvSpPr>
         <p:spPr>
           <a:xfrm>
-            <a:off x="3378708" y="5567782"/>
+            <a:off x="3378708" y="5649163"/>
             <a:ext cx="2601468" cy="274320"/>
           </a:xfrm>
           <a:prstGeom prst="rect">
@@ -15150,7 +15149,7 @@
         </p:nvSpPr>
         <p:spPr>
           <a:xfrm>
-            <a:off x="3451860" y="5842102"/>
+            <a:off x="3451860" y="5923483"/>
             <a:ext cx="2455164" cy="274320"/>
           </a:xfrm>
           <a:prstGeom prst="rect">
@@ -15205,8 +15204,8 @@
         </p:blipFill>
         <p:spPr>
           <a:xfrm>
-            <a:off x="5541264" y="5751576"/>
-            <a:ext cx="329184" cy="329184"/>
+            <a:off x="5577840" y="4210812"/>
+            <a:ext cx="310896" cy="310896"/>
           </a:xfrm>
           <a:prstGeom prst="rect">
             <a:avLst/>
@@ -15249,7 +15248,7 @@
       </p:sp>
       <p:pic>
         <p:nvPicPr>
-          <p:cNvPr id="41" name="dibujo_6" descr="C:\Users\Chingu\AppData\Local\Temp\claude\C--Users-Chingu-Desktop-ACADEMIASEULWEB\d4111e1b-5523-44ea-97b2-b1a1d9545b9e\scratchpad\decks\cache\ec8aa4ed8e98ec9db8.png"/>
+          <p:cNvPr id="41" name="dibujo_6" descr="C:\Users\Chingu\AppData\Local\Temp\claude\C--Users-Chingu-Desktop-ACADEMIASEULWEB\d4111e1b-5523-44ea-97b2-b1a1d9545b9e\scratchpad\decks\cache\img_dfbe7daf521a89ae.png"/>
           <p:cNvPicPr>
             <a:picLocks noChangeAspect="1"/>
           </p:cNvPicPr>
@@ -15263,8 +15262,8 @@
         </p:blipFill>
         <p:spPr>
           <a:xfrm>
-            <a:off x="7082257" y="4247388"/>
-            <a:ext cx="854507" cy="854507"/>
+            <a:off x="7021220" y="4247388"/>
+            <a:ext cx="976579" cy="976579"/>
           </a:xfrm>
           <a:prstGeom prst="rect">
             <a:avLst/>
@@ -15279,8 +15278,8 @@
         </p:nvSpPr>
         <p:spPr>
           <a:xfrm>
-            <a:off x="6208776" y="5120183"/>
-            <a:ext cx="2601468" cy="447599"/>
+            <a:off x="6208776" y="5242255"/>
+            <a:ext cx="2601468" cy="406908"/>
           </a:xfrm>
           <a:prstGeom prst="rect">
             <a:avLst/>
@@ -15298,7 +15297,7 @@
               <a:buNone/>
             </a:pPr>
             <a:r>
-              <a:rPr lang="ko-KR" altLang="en-US" sz="2800" b="1" dirty="0">
+              <a:rPr lang="ko-KR" altLang="en-US" sz="2500" b="1" dirty="0">
                 <a:solidFill>
                   <a:srgbClr val="4236F6"/>
                 </a:solidFill>
@@ -15308,7 +15307,7 @@
               </a:rPr>
               <a:t>스페인</a:t>
             </a:r>
-            <a:endParaRPr lang="en-US" sz="2800" dirty="0"/>
+            <a:endParaRPr lang="en-US" sz="2500" dirty="0"/>
           </a:p>
         </p:txBody>
       </p:sp>
@@ -15320,7 +15319,7 @@
         </p:nvSpPr>
         <p:spPr>
           <a:xfrm>
-            <a:off x="6208776" y="5567782"/>
+            <a:off x="6208776" y="5649163"/>
             <a:ext cx="2601468" cy="274320"/>
           </a:xfrm>
           <a:prstGeom prst="rect">
@@ -15358,7 +15357,7 @@
         </p:nvSpPr>
         <p:spPr>
           <a:xfrm>
-            <a:off x="6281928" y="5842102"/>
+            <a:off x="6281928" y="5923483"/>
             <a:ext cx="2455164" cy="274320"/>
           </a:xfrm>
           <a:prstGeom prst="rect">
@@ -15413,8 +15412,8 @@
         </p:blipFill>
         <p:spPr>
           <a:xfrm>
-            <a:off x="8371332" y="5751576"/>
-            <a:ext cx="329184" cy="329184"/>
+            <a:off x="8407908" y="4210812"/>
+            <a:ext cx="310896" cy="310896"/>
           </a:xfrm>
           <a:prstGeom prst="rect">
             <a:avLst/>
@@ -15457,7 +15456,7 @@
       </p:sp>
       <p:pic>
         <p:nvPicPr>
-          <p:cNvPr id="47" name="dibujo_7" descr="C:\Users\Chingu\AppData\Local\Temp\claude\C--Users-Chingu-Desktop-ACADEMIASEULWEB\d4111e1b-5523-44ea-97b2-b1a1d9545b9e\scratchpad\decks\cache\ebafb8eab5ad.png"/>
+          <p:cNvPr id="47" name="dibujo_7" descr="C:\Users\Chingu\AppData\Local\Temp\claude\C--Users-Chingu-Desktop-ACADEMIASEULWEB\d4111e1b-5523-44ea-97b2-b1a1d9545b9e\scratchpad\decks\cache\img_e0a8241f7bf12ea2.png"/>
           <p:cNvPicPr>
             <a:picLocks noChangeAspect="1"/>
           </p:cNvPicPr>
@@ -15471,8 +15470,8 @@
         </p:blipFill>
         <p:spPr>
           <a:xfrm>
-            <a:off x="9912325" y="4247388"/>
-            <a:ext cx="854507" cy="854507"/>
+            <a:off x="9851288" y="4247388"/>
+            <a:ext cx="976579" cy="976579"/>
           </a:xfrm>
           <a:prstGeom prst="rect">
             <a:avLst/>
@@ -15487,8 +15486,8 @@
         </p:nvSpPr>
         <p:spPr>
           <a:xfrm>
-            <a:off x="9038844" y="5120183"/>
-            <a:ext cx="2601468" cy="447599"/>
+            <a:off x="9038844" y="5242255"/>
+            <a:ext cx="2601468" cy="406908"/>
           </a:xfrm>
           <a:prstGeom prst="rect">
             <a:avLst/>
@@ -15506,7 +15505,7 @@
               <a:buNone/>
             </a:pPr>
             <a:r>
-              <a:rPr lang="ko-KR" altLang="en-US" sz="2800" b="1" dirty="0">
+              <a:rPr lang="ko-KR" altLang="en-US" sz="2500" b="1" dirty="0">
                 <a:solidFill>
                   <a:srgbClr val="4236F6"/>
                 </a:solidFill>
@@ -15516,7 +15515,7 @@
               </a:rPr>
               <a:t>미국</a:t>
             </a:r>
-            <a:endParaRPr lang="en-US" sz="2800" dirty="0"/>
+            <a:endParaRPr lang="en-US" sz="2500" dirty="0"/>
           </a:p>
         </p:txBody>
       </p:sp>
@@ -15528,7 +15527,7 @@
         </p:nvSpPr>
         <p:spPr>
           <a:xfrm>
-            <a:off x="9038844" y="5567782"/>
+            <a:off x="9038844" y="5649163"/>
             <a:ext cx="2601468" cy="274320"/>
           </a:xfrm>
           <a:prstGeom prst="rect">
@@ -15566,7 +15565,7 @@
         </p:nvSpPr>
         <p:spPr>
           <a:xfrm>
-            <a:off x="9111996" y="5842102"/>
+            <a:off x="9111996" y="5923483"/>
             <a:ext cx="2455164" cy="274320"/>
           </a:xfrm>
           <a:prstGeom prst="rect">
@@ -15621,8 +15620,8 @@
         </p:blipFill>
         <p:spPr>
           <a:xfrm>
-            <a:off x="11201400" y="5751576"/>
-            <a:ext cx="329184" cy="329184"/>
+            <a:off x="11237976" y="4210812"/>
+            <a:ext cx="310896" cy="310896"/>
           </a:xfrm>
           <a:prstGeom prst="rect">
             <a:avLst/>
@@ -16033,7 +16032,7 @@
         <p:spPr>
           <a:xfrm>
             <a:off x="548640" y="1325880"/>
-            <a:ext cx="11064240" cy="457200"/>
+            <a:ext cx="11091672" cy="457200"/>
           </a:xfrm>
           <a:prstGeom prst="rect">
             <a:avLst/>
@@ -16158,7 +16157,7 @@
       </p:sp>
       <p:pic>
         <p:nvPicPr>
-          <p:cNvPr id="5" name="dibujo_0" descr="C:\Users\Chingu\AppData\Local\Temp\claude\C--Users-Chingu-Desktop-ACADEMIASEULWEB\d4111e1b-5523-44ea-97b2-b1a1d9545b9e\scratchpad\decks\cache\ed9599ec839d.png"/>
+          <p:cNvPr id="5" name="dibujo_0" descr="C:\Users\Chingu\AppData\Local\Temp\claude\C--Users-Chingu-Desktop-ACADEMIASEULWEB\d4111e1b-5523-44ea-97b2-b1a1d9545b9e\scratchpad\decks\cache\img_b7d60e8ac81a8ff2.png"/>
           <p:cNvPicPr>
             <a:picLocks noChangeAspect="1"/>
           </p:cNvPicPr>
@@ -16172,8 +16171,8 @@
         </p:blipFill>
         <p:spPr>
           <a:xfrm>
-            <a:off x="1133970" y="1984248"/>
-            <a:ext cx="1430807" cy="1430807"/>
+            <a:off x="1042919" y="1984248"/>
+            <a:ext cx="1612910" cy="1612910"/>
           </a:xfrm>
           <a:prstGeom prst="rect">
             <a:avLst/>
@@ -16188,8 +16187,8 @@
         </p:nvSpPr>
         <p:spPr>
           <a:xfrm>
-            <a:off x="548640" y="3433343"/>
-            <a:ext cx="2601468" cy="945490"/>
+            <a:off x="548640" y="3615446"/>
+            <a:ext cx="2601468" cy="859536"/>
           </a:xfrm>
           <a:prstGeom prst="rect">
             <a:avLst/>
@@ -16229,7 +16228,7 @@
         </p:nvSpPr>
         <p:spPr>
           <a:xfrm>
-            <a:off x="548640" y="4378833"/>
+            <a:off x="548640" y="4474982"/>
             <a:ext cx="2601468" cy="274320"/>
           </a:xfrm>
           <a:prstGeom prst="rect">
@@ -16267,8 +16266,8 @@
         </p:nvSpPr>
         <p:spPr>
           <a:xfrm>
-            <a:off x="621792" y="4653153"/>
-            <a:ext cx="2455164" cy="1107567"/>
+            <a:off x="621792" y="4749302"/>
+            <a:ext cx="2455164" cy="1349746"/>
           </a:xfrm>
           <a:prstGeom prst="rect">
             <a:avLst/>
@@ -16322,8 +16321,8 @@
         </p:blipFill>
         <p:spPr>
           <a:xfrm>
-            <a:off x="2711196" y="5751576"/>
-            <a:ext cx="329184" cy="329184"/>
+            <a:off x="2747772" y="1947672"/>
+            <a:ext cx="310896" cy="310896"/>
           </a:xfrm>
           <a:prstGeom prst="rect">
             <a:avLst/>
@@ -16366,7 +16365,7 @@
       </p:sp>
       <p:pic>
         <p:nvPicPr>
-          <p:cNvPr id="11" name="dibujo_1" descr="C:\Users\Chingu\AppData\Local\Temp\claude\C--Users-Chingu-Desktop-ACADEMIASEULWEB\d4111e1b-5523-44ea-97b2-b1a1d9545b9e\scratchpad\decks\cache\ec84a0ec839deb8b98.png"/>
+          <p:cNvPr id="11" name="dibujo_1" descr="C:\Users\Chingu\AppData\Local\Temp\claude\C--Users-Chingu-Desktop-ACADEMIASEULWEB\d4111e1b-5523-44ea-97b2-b1a1d9545b9e\scratchpad\decks\cache\img_bbd1588d81724b77.png"/>
           <p:cNvPicPr>
             <a:picLocks noChangeAspect="1"/>
           </p:cNvPicPr>
@@ -16380,8 +16379,8 @@
         </p:blipFill>
         <p:spPr>
           <a:xfrm>
-            <a:off x="3964038" y="1984248"/>
-            <a:ext cx="1430807" cy="1430807"/>
+            <a:off x="3872987" y="1984248"/>
+            <a:ext cx="1612910" cy="1612910"/>
           </a:xfrm>
           <a:prstGeom prst="rect">
             <a:avLst/>
@@ -16396,8 +16395,8 @@
         </p:nvSpPr>
         <p:spPr>
           <a:xfrm>
-            <a:off x="3378708" y="3433343"/>
-            <a:ext cx="2601468" cy="945490"/>
+            <a:off x="3378708" y="3615446"/>
+            <a:ext cx="2601468" cy="859536"/>
           </a:xfrm>
           <a:prstGeom prst="rect">
             <a:avLst/>
@@ -16437,7 +16436,7 @@
         </p:nvSpPr>
         <p:spPr>
           <a:xfrm>
-            <a:off x="3378708" y="4378833"/>
+            <a:off x="3378708" y="4474982"/>
             <a:ext cx="2601468" cy="274320"/>
           </a:xfrm>
           <a:prstGeom prst="rect">
@@ -16475,8 +16474,8 @@
         </p:nvSpPr>
         <p:spPr>
           <a:xfrm>
-            <a:off x="3451860" y="4653153"/>
-            <a:ext cx="2455164" cy="1107567"/>
+            <a:off x="3451860" y="4749302"/>
+            <a:ext cx="2455164" cy="1349746"/>
           </a:xfrm>
           <a:prstGeom prst="rect">
             <a:avLst/>
@@ -16530,8 +16529,8 @@
         </p:blipFill>
         <p:spPr>
           <a:xfrm>
-            <a:off x="5541264" y="5751576"/>
-            <a:ext cx="329184" cy="329184"/>
+            <a:off x="5577840" y="1947672"/>
+            <a:ext cx="310896" cy="310896"/>
           </a:xfrm>
           <a:prstGeom prst="rect">
             <a:avLst/>
@@ -16574,7 +16573,7 @@
       </p:sp>
       <p:pic>
         <p:nvPicPr>
-          <p:cNvPr id="17" name="dibujo_2" descr="C:\Users\Chingu\AppData\Local\Temp\claude\C--Users-Chingu-Desktop-ACADEMIASEULWEB\d4111e1b-5523-44ea-97b2-b1a1d9545b9e\scratchpad\decks\cache\ed9a8cec82acec9b90.png"/>
+          <p:cNvPr id="17" name="dibujo_2" descr="C:\Users\Chingu\AppData\Local\Temp\claude\C--Users-Chingu-Desktop-ACADEMIASEULWEB\d4111e1b-5523-44ea-97b2-b1a1d9545b9e\scratchpad\decks\cache\img_591416f0b743aa3d.png"/>
           <p:cNvPicPr>
             <a:picLocks noChangeAspect="1"/>
           </p:cNvPicPr>
@@ -16588,8 +16587,8 @@
         </p:blipFill>
         <p:spPr>
           <a:xfrm>
-            <a:off x="6794106" y="1984248"/>
-            <a:ext cx="1430807" cy="1430807"/>
+            <a:off x="6703055" y="1984248"/>
+            <a:ext cx="1612910" cy="1612910"/>
           </a:xfrm>
           <a:prstGeom prst="rect">
             <a:avLst/>
@@ -16604,8 +16603,8 @@
         </p:nvSpPr>
         <p:spPr>
           <a:xfrm>
-            <a:off x="6208776" y="3433343"/>
-            <a:ext cx="2601468" cy="945490"/>
+            <a:off x="6208776" y="3615446"/>
+            <a:ext cx="2601468" cy="859536"/>
           </a:xfrm>
           <a:prstGeom prst="rect">
             <a:avLst/>
@@ -16645,7 +16644,7 @@
         </p:nvSpPr>
         <p:spPr>
           <a:xfrm>
-            <a:off x="6208776" y="4378833"/>
+            <a:off x="6208776" y="4474982"/>
             <a:ext cx="2601468" cy="274320"/>
           </a:xfrm>
           <a:prstGeom prst="rect">
@@ -16683,8 +16682,8 @@
         </p:nvSpPr>
         <p:spPr>
           <a:xfrm>
-            <a:off x="6281928" y="4653153"/>
-            <a:ext cx="2455164" cy="1107567"/>
+            <a:off x="6281928" y="4749302"/>
+            <a:ext cx="2455164" cy="1349746"/>
           </a:xfrm>
           <a:prstGeom prst="rect">
             <a:avLst/>
@@ -16738,8 +16737,8 @@
         </p:blipFill>
         <p:spPr>
           <a:xfrm>
-            <a:off x="8371332" y="5751576"/>
-            <a:ext cx="329184" cy="329184"/>
+            <a:off x="8407908" y="1947672"/>
+            <a:ext cx="310896" cy="310896"/>
           </a:xfrm>
           <a:prstGeom prst="rect">
             <a:avLst/>
@@ -16782,7 +16781,7 @@
       </p:sp>
       <p:pic>
         <p:nvPicPr>
-          <p:cNvPr id="23" name="dibujo_3" descr="C:\Users\Chingu\AppData\Local\Temp\claude\C--Users-Chingu-Desktop-ACADEMIASEULWEB\d4111e1b-5523-44ea-97b2-b1a1d9545b9e\scratchpad\decks\cache\ec9d98ec82ac.png"/>
+          <p:cNvPr id="23" name="dibujo_3" descr="C:\Users\Chingu\AppData\Local\Temp\claude\C--Users-Chingu-Desktop-ACADEMIASEULWEB\d4111e1b-5523-44ea-97b2-b1a1d9545b9e\scratchpad\decks\cache\img_7b61a9ac9f11068c.png"/>
           <p:cNvPicPr>
             <a:picLocks noChangeAspect="1"/>
           </p:cNvPicPr>
@@ -16796,8 +16795,8 @@
         </p:blipFill>
         <p:spPr>
           <a:xfrm>
-            <a:off x="9624174" y="1984248"/>
-            <a:ext cx="1430807" cy="1430807"/>
+            <a:off x="9533123" y="1984248"/>
+            <a:ext cx="1612910" cy="1612910"/>
           </a:xfrm>
           <a:prstGeom prst="rect">
             <a:avLst/>
@@ -16812,8 +16811,8 @@
         </p:nvSpPr>
         <p:spPr>
           <a:xfrm>
-            <a:off x="9038844" y="3433343"/>
-            <a:ext cx="2601468" cy="945490"/>
+            <a:off x="9038844" y="3615446"/>
+            <a:ext cx="2601468" cy="859536"/>
           </a:xfrm>
           <a:prstGeom prst="rect">
             <a:avLst/>
@@ -16853,7 +16852,7 @@
         </p:nvSpPr>
         <p:spPr>
           <a:xfrm>
-            <a:off x="9038844" y="4378833"/>
+            <a:off x="9038844" y="4474982"/>
             <a:ext cx="2601468" cy="274320"/>
           </a:xfrm>
           <a:prstGeom prst="rect">
@@ -16891,8 +16890,8 @@
         </p:nvSpPr>
         <p:spPr>
           <a:xfrm>
-            <a:off x="9111996" y="4653153"/>
-            <a:ext cx="2455164" cy="1107567"/>
+            <a:off x="9111996" y="4749302"/>
+            <a:ext cx="2455164" cy="1349746"/>
           </a:xfrm>
           <a:prstGeom prst="rect">
             <a:avLst/>
@@ -16946,8 +16945,8 @@
         </p:blipFill>
         <p:spPr>
           <a:xfrm>
-            <a:off x="11201400" y="5751576"/>
-            <a:ext cx="329184" cy="329184"/>
+            <a:off x="11237976" y="1947672"/>
+            <a:ext cx="310896" cy="310896"/>
           </a:xfrm>
           <a:prstGeom prst="rect">
             <a:avLst/>
@@ -17257,7 +17256,7 @@
         <p:spPr>
           <a:xfrm>
             <a:off x="548640" y="1325880"/>
-            <a:ext cx="11064240" cy="548640"/>
+            <a:ext cx="11091672" cy="548640"/>
           </a:xfrm>
           <a:prstGeom prst="rect">
             <a:avLst/>
@@ -18481,7 +18480,7 @@
         <p:spPr>
           <a:xfrm>
             <a:off x="548640" y="1325880"/>
-            <a:ext cx="11064240" cy="457200"/>
+            <a:ext cx="11091672" cy="457200"/>
           </a:xfrm>
           <a:prstGeom prst="rect">
             <a:avLst/>
@@ -18560,8 +18559,8 @@
         </p:blipFill>
         <p:spPr>
           <a:xfrm>
-            <a:off x="1893799" y="1984248"/>
-            <a:ext cx="854507" cy="854507"/>
+            <a:off x="1832762" y="1984248"/>
+            <a:ext cx="976579" cy="976579"/>
           </a:xfrm>
           <a:prstGeom prst="rect">
             <a:avLst/>
@@ -18576,8 +18575,8 @@
         </p:nvSpPr>
         <p:spPr>
           <a:xfrm>
-            <a:off x="548640" y="2857043"/>
-            <a:ext cx="3544824" cy="447599"/>
+            <a:off x="548640" y="2979115"/>
+            <a:ext cx="3544824" cy="406908"/>
           </a:xfrm>
           <a:prstGeom prst="rect">
             <a:avLst/>
@@ -18595,7 +18594,7 @@
               <a:buNone/>
             </a:pPr>
             <a:r>
-              <a:rPr lang="ko-KR" altLang="en-US" sz="2800" b="1" dirty="0">
+              <a:rPr lang="ko-KR" altLang="en-US" sz="2300" b="1" dirty="0">
                 <a:solidFill>
                   <a:srgbClr val="4236F6"/>
                 </a:solidFill>
@@ -18605,7 +18604,7 @@
               </a:rPr>
               <a:t>이름</a:t>
             </a:r>
-            <a:endParaRPr lang="en-US" sz="2800" dirty="0"/>
+            <a:endParaRPr lang="en-US" sz="2300" dirty="0"/>
           </a:p>
         </p:txBody>
       </p:sp>
@@ -18617,7 +18616,7 @@
         </p:nvSpPr>
         <p:spPr>
           <a:xfrm>
-            <a:off x="548640" y="3304642"/>
+            <a:off x="548640" y="3386023"/>
             <a:ext cx="3544824" cy="274320"/>
           </a:xfrm>
           <a:prstGeom prst="rect">
@@ -18655,7 +18654,7 @@
         </p:nvSpPr>
         <p:spPr>
           <a:xfrm>
-            <a:off x="621792" y="3578962"/>
+            <a:off x="621792" y="3660343"/>
             <a:ext cx="3398520" cy="274320"/>
           </a:xfrm>
           <a:prstGeom prst="rect">
@@ -18710,8 +18709,8 @@
         </p:blipFill>
         <p:spPr>
           <a:xfrm>
-            <a:off x="3654552" y="3488436"/>
-            <a:ext cx="329184" cy="329184"/>
+            <a:off x="3691128" y="1947672"/>
+            <a:ext cx="310896" cy="310896"/>
           </a:xfrm>
           <a:prstGeom prst="rect">
             <a:avLst/>
@@ -18779,7 +18778,7 @@
               <a:buNone/>
             </a:pPr>
             <a:r>
-              <a:rPr lang="ko-KR" altLang="en-US" sz="3400" b="1" dirty="0">
+              <a:rPr lang="ko-KR" altLang="en-US" sz="2300" b="1" dirty="0">
                 <a:solidFill>
                   <a:srgbClr val="4236F6"/>
                 </a:solidFill>
@@ -18790,14 +18789,14 @@
               <a:t>이름이 뭐예요</a:t>
             </a:r>
             <a:r>
-              <a:rPr lang="en-US" sz="3400" b="1" dirty="0">
+              <a:rPr lang="en-US" sz="2300" b="1" dirty="0">
                 <a:solidFill>
                   <a:srgbClr val="4236F6"/>
                 </a:solidFill>
               </a:rPr>
               <a:t>?</a:t>
             </a:r>
-            <a:endParaRPr lang="en-US" sz="3400" dirty="0"/>
+            <a:endParaRPr lang="en-US" sz="2300" dirty="0"/>
           </a:p>
         </p:txBody>
       </p:sp>
@@ -18810,7 +18809,7 @@
         <p:spPr>
           <a:xfrm>
             <a:off x="4395216" y="2920136"/>
-            <a:ext cx="3398520" cy="577444"/>
+            <a:ext cx="3398520" cy="915772"/>
           </a:xfrm>
           <a:prstGeom prst="rect">
             <a:avLst/>
@@ -18864,8 +18863,8 @@
         </p:blipFill>
         <p:spPr>
           <a:xfrm>
-            <a:off x="7427976" y="3488436"/>
-            <a:ext cx="329184" cy="329184"/>
+            <a:off x="7464552" y="1947672"/>
+            <a:ext cx="310896" cy="310896"/>
           </a:xfrm>
           <a:prstGeom prst="rect">
             <a:avLst/>
@@ -18922,8 +18921,8 @@
         </p:blipFill>
         <p:spPr>
           <a:xfrm>
-            <a:off x="9440647" y="1984248"/>
-            <a:ext cx="854507" cy="854507"/>
+            <a:off x="9379610" y="1984248"/>
+            <a:ext cx="976579" cy="976579"/>
           </a:xfrm>
           <a:prstGeom prst="rect">
             <a:avLst/>
@@ -18938,8 +18937,8 @@
         </p:nvSpPr>
         <p:spPr>
           <a:xfrm>
-            <a:off x="8095488" y="2857043"/>
-            <a:ext cx="3544824" cy="447599"/>
+            <a:off x="8095488" y="2979115"/>
+            <a:ext cx="3544824" cy="406908"/>
           </a:xfrm>
           <a:prstGeom prst="rect">
             <a:avLst/>
@@ -18957,7 +18956,7 @@
               <a:buNone/>
             </a:pPr>
             <a:r>
-              <a:rPr lang="ko-KR" altLang="en-US" sz="2800" b="1" dirty="0">
+              <a:rPr lang="ko-KR" altLang="en-US" sz="2300" b="1" dirty="0">
                 <a:solidFill>
                   <a:srgbClr val="4236F6"/>
                 </a:solidFill>
@@ -18967,7 +18966,7 @@
               </a:rPr>
               <a:t>나라</a:t>
             </a:r>
-            <a:endParaRPr lang="en-US" sz="2800" dirty="0"/>
+            <a:endParaRPr lang="en-US" sz="2300" dirty="0"/>
           </a:p>
         </p:txBody>
       </p:sp>
@@ -18979,7 +18978,7 @@
         </p:nvSpPr>
         <p:spPr>
           <a:xfrm>
-            <a:off x="8095488" y="3304642"/>
+            <a:off x="8095488" y="3386023"/>
             <a:ext cx="3544824" cy="274320"/>
           </a:xfrm>
           <a:prstGeom prst="rect">
@@ -19017,7 +19016,7 @@
         </p:nvSpPr>
         <p:spPr>
           <a:xfrm>
-            <a:off x="8168640" y="3578962"/>
+            <a:off x="8168640" y="3660343"/>
             <a:ext cx="3398520" cy="274320"/>
           </a:xfrm>
           <a:prstGeom prst="rect">
@@ -19072,8 +19071,8 @@
         </p:blipFill>
         <p:spPr>
           <a:xfrm>
-            <a:off x="11201400" y="3488436"/>
-            <a:ext cx="329184" cy="329184"/>
+            <a:off x="11237976" y="1947672"/>
+            <a:ext cx="310896" cy="310896"/>
           </a:xfrm>
           <a:prstGeom prst="rect">
             <a:avLst/>
@@ -19172,7 +19171,7 @@
         <p:spPr>
           <a:xfrm>
             <a:off x="621792" y="5183276"/>
-            <a:ext cx="3398520" cy="577444"/>
+            <a:ext cx="3398520" cy="915772"/>
           </a:xfrm>
           <a:prstGeom prst="rect">
             <a:avLst/>
@@ -19251,8 +19250,8 @@
         </p:blipFill>
         <p:spPr>
           <a:xfrm>
-            <a:off x="5667223" y="4247388"/>
-            <a:ext cx="854507" cy="854507"/>
+            <a:off x="5606186" y="4247388"/>
+            <a:ext cx="976579" cy="976579"/>
           </a:xfrm>
           <a:prstGeom prst="rect">
             <a:avLst/>
@@ -19267,8 +19266,8 @@
         </p:nvSpPr>
         <p:spPr>
           <a:xfrm>
-            <a:off x="4322064" y="5120183"/>
-            <a:ext cx="3544824" cy="447599"/>
+            <a:off x="4322064" y="5242255"/>
+            <a:ext cx="3544824" cy="406908"/>
           </a:xfrm>
           <a:prstGeom prst="rect">
             <a:avLst/>
@@ -19286,7 +19285,7 @@
               <a:buNone/>
             </a:pPr>
             <a:r>
-              <a:rPr lang="ko-KR" altLang="en-US" sz="2800" b="1" dirty="0">
+              <a:rPr lang="ko-KR" altLang="en-US" sz="2300" b="1" dirty="0">
                 <a:solidFill>
                   <a:srgbClr val="4236F6"/>
                 </a:solidFill>
@@ -19296,7 +19295,7 @@
               </a:rPr>
               <a:t>반갑습니다</a:t>
             </a:r>
-            <a:endParaRPr lang="en-US" sz="2800" dirty="0"/>
+            <a:endParaRPr lang="en-US" sz="2300" dirty="0"/>
           </a:p>
         </p:txBody>
       </p:sp>
@@ -19308,7 +19307,7 @@
         </p:nvSpPr>
         <p:spPr>
           <a:xfrm>
-            <a:off x="4322064" y="5567782"/>
+            <a:off x="4322064" y="5649163"/>
             <a:ext cx="3544824" cy="274320"/>
           </a:xfrm>
           <a:prstGeom prst="rect">
@@ -19346,7 +19345,7 @@
         </p:nvSpPr>
         <p:spPr>
           <a:xfrm>
-            <a:off x="4395216" y="5842102"/>
+            <a:off x="4395216" y="5923483"/>
             <a:ext cx="3398520" cy="274320"/>
           </a:xfrm>
           <a:prstGeom prst="rect">
@@ -19401,8 +19400,8 @@
         </p:blipFill>
         <p:spPr>
           <a:xfrm>
-            <a:off x="7427976" y="5751576"/>
-            <a:ext cx="329184" cy="329184"/>
+            <a:off x="7464552" y="4210812"/>
+            <a:ext cx="310896" cy="310896"/>
           </a:xfrm>
           <a:prstGeom prst="rect">
             <a:avLst/>
@@ -19673,7 +19672,7 @@
         <p:spPr>
           <a:xfrm>
             <a:off x="548640" y="1325880"/>
-            <a:ext cx="11064240" cy="457200"/>
+            <a:ext cx="11091672" cy="457200"/>
           </a:xfrm>
           <a:prstGeom prst="rect">
             <a:avLst/>
@@ -19711,7 +19710,7 @@
           <p:nvPr>
             <p:extLst>
               <p:ext uri="{D42A27DB-BD31-4B8C-83A1-F6EECF244321}">
-                <p14:modId xmlns:p14="http://schemas.microsoft.com/office/powerpoint/2010/main" val="4072262131"/>
+                <p14:modId xmlns:p14="http://schemas.microsoft.com/office/powerpoint/2010/main" val="4076895334"/>
               </p:ext>
             </p:extLst>
           </p:nvPr>
@@ -21371,7 +21370,7 @@
         <p:spPr>
           <a:xfrm>
             <a:off x="548640" y="1325880"/>
-            <a:ext cx="11064240" cy="457200"/>
+            <a:ext cx="11091672" cy="457200"/>
           </a:xfrm>
           <a:prstGeom prst="rect">
             <a:avLst/>
@@ -21409,7 +21408,7 @@
           <p:nvPr>
             <p:extLst>
               <p:ext uri="{D42A27DB-BD31-4B8C-83A1-F6EECF244321}">
-                <p14:modId xmlns:p14="http://schemas.microsoft.com/office/powerpoint/2010/main" val="3823080456"/>
+                <p14:modId xmlns:p14="http://schemas.microsoft.com/office/powerpoint/2010/main" val="1995209953"/>
               </p:ext>
             </p:extLst>
           </p:nvPr>
@@ -23052,16 +23051,40 @@
           </a:p>
         </p:txBody>
       </p:sp>
-      <p:sp>
-        <p:nvSpPr>
-          <p:cNvPr id="3" name="Text 1"/>
+      <p:pic>
+        <p:nvPicPr>
+          <p:cNvPr id="3" name="imagen" descr="C:\Users\Chingu\AppData\Local\Temp\claude\C--Users-Chingu-Desktop-ACADEMIASEULWEB\d4111e1b-5523-44ea-97b2-b1a1d9545b9e\scratchpad\decks\cache\img_ef157fb0bb8b36f3.png"/>
+          <p:cNvPicPr>
+            <a:picLocks noChangeAspect="1"/>
+          </p:cNvPicPr>
+          <p:nvPr/>
+        </p:nvPicPr>
+        <p:blipFill>
+          <a:blip r:embed="rId3"/>
+          <a:stretch>
+            <a:fillRect/>
+          </a:stretch>
+        </p:blipFill>
+        <p:spPr>
+          <a:xfrm>
+            <a:off x="7754112" y="1508760"/>
+            <a:ext cx="3886200" cy="4480560"/>
+          </a:xfrm>
+          <a:prstGeom prst="rect">
+            <a:avLst/>
+          </a:prstGeom>
+        </p:spPr>
+      </p:pic>
+      <p:sp>
+        <p:nvSpPr>
+          <p:cNvPr id="4" name="Text 1"/>
           <p:cNvSpPr txBox="1"/>
           <p:nvPr/>
         </p:nvSpPr>
         <p:spPr>
           <a:xfrm>
             <a:off x="548640" y="1325880"/>
-            <a:ext cx="11064240" cy="457200"/>
+            <a:ext cx="6931152" cy="457200"/>
           </a:xfrm>
           <a:prstGeom prst="rect">
             <a:avLst/>
@@ -23092,18 +23115,18 @@
       </p:sp>
       <p:sp>
         <p:nvSpPr>
-          <p:cNvPr id="4" name="col_0"/>
+          <p:cNvPr id="5" name="col_0"/>
           <p:cNvSpPr/>
           <p:nvPr/>
         </p:nvSpPr>
         <p:spPr>
           <a:xfrm>
             <a:off x="548640" y="1874520"/>
-            <a:ext cx="5385816" cy="4297680"/>
+            <a:ext cx="3305556" cy="4297680"/>
           </a:xfrm>
           <a:prstGeom prst="roundRect">
             <a:avLst>
-              <a:gd name="adj" fmla="val 3191"/>
+              <a:gd name="adj" fmla="val 4149"/>
             </a:avLst>
           </a:prstGeom>
           <a:solidFill>
@@ -23119,14 +23142,14 @@
       </p:sp>
       <p:sp>
         <p:nvSpPr>
-          <p:cNvPr id="5" name="Text 3"/>
+          <p:cNvPr id="6" name="Text 3"/>
           <p:cNvSpPr txBox="1"/>
           <p:nvPr/>
         </p:nvSpPr>
         <p:spPr>
           <a:xfrm>
             <a:off x="777240" y="2057400"/>
-            <a:ext cx="4928616" cy="548640"/>
+            <a:ext cx="2848356" cy="548640"/>
           </a:xfrm>
           <a:prstGeom prst="rect">
             <a:avLst/>
@@ -23157,14 +23180,14 @@
       </p:sp>
       <p:sp>
         <p:nvSpPr>
-          <p:cNvPr id="6" name="Text 4"/>
+          <p:cNvPr id="7" name="Text 4"/>
           <p:cNvSpPr txBox="1"/>
           <p:nvPr/>
         </p:nvSpPr>
         <p:spPr>
           <a:xfrm>
             <a:off x="777240" y="2651760"/>
-            <a:ext cx="4928616" cy="914400"/>
+            <a:ext cx="2848356" cy="914400"/>
           </a:xfrm>
           <a:prstGeom prst="rect">
             <a:avLst/>
@@ -23182,7 +23205,7 @@
               <a:buNone/>
             </a:pPr>
             <a:r>
-              <a:rPr lang="ko-KR" altLang="en-US" sz="5400" b="1" dirty="0">
+              <a:rPr lang="ko-KR" altLang="en-US" sz="4000" b="1" dirty="0">
                 <a:solidFill>
                   <a:srgbClr val="4236F6"/>
                 </a:solidFill>
@@ -23192,20 +23215,20 @@
               </a:rPr>
               <a:t>안녕하세요</a:t>
             </a:r>
-            <a:endParaRPr lang="en-US" sz="5400" dirty="0"/>
+            <a:endParaRPr lang="en-US" sz="4000" dirty="0"/>
           </a:p>
         </p:txBody>
       </p:sp>
       <p:sp>
         <p:nvSpPr>
-          <p:cNvPr id="7" name="lista"/>
+          <p:cNvPr id="8" name="lista"/>
           <p:cNvSpPr txBox="1"/>
           <p:nvPr/>
         </p:nvSpPr>
         <p:spPr>
           <a:xfrm>
             <a:off x="731520" y="3657600"/>
-            <a:ext cx="5020056" cy="2377440"/>
+            <a:ext cx="2939796" cy="2377440"/>
           </a:xfrm>
           <a:prstGeom prst="rect">
             <a:avLst/>
@@ -23280,18 +23303,18 @@
       </p:sp>
       <p:sp>
         <p:nvSpPr>
-          <p:cNvPr id="8" name="col_1"/>
+          <p:cNvPr id="9" name="col_1"/>
           <p:cNvSpPr/>
           <p:nvPr/>
         </p:nvSpPr>
         <p:spPr>
           <a:xfrm>
-            <a:off x="6254496" y="1874520"/>
-            <a:ext cx="5385816" cy="4297680"/>
+            <a:off x="4174236" y="1874520"/>
+            <a:ext cx="3305556" cy="4297680"/>
           </a:xfrm>
           <a:prstGeom prst="roundRect">
             <a:avLst>
-              <a:gd name="adj" fmla="val 3191"/>
+              <a:gd name="adj" fmla="val 4149"/>
             </a:avLst>
           </a:prstGeom>
           <a:solidFill>
@@ -23307,14 +23330,14 @@
       </p:sp>
       <p:sp>
         <p:nvSpPr>
-          <p:cNvPr id="9" name="Text 7"/>
+          <p:cNvPr id="10" name="Text 7"/>
           <p:cNvSpPr txBox="1"/>
           <p:nvPr/>
         </p:nvSpPr>
         <p:spPr>
           <a:xfrm>
-            <a:off x="6483096" y="2057400"/>
-            <a:ext cx="4928616" cy="548640"/>
+            <a:off x="4402836" y="2057400"/>
+            <a:ext cx="2848356" cy="548640"/>
           </a:xfrm>
           <a:prstGeom prst="rect">
             <a:avLst/>
@@ -23345,14 +23368,14 @@
       </p:sp>
       <p:sp>
         <p:nvSpPr>
-          <p:cNvPr id="10" name="Text 8"/>
+          <p:cNvPr id="11" name="Text 8"/>
           <p:cNvSpPr txBox="1"/>
           <p:nvPr/>
         </p:nvSpPr>
         <p:spPr>
           <a:xfrm>
-            <a:off x="6483096" y="2651760"/>
-            <a:ext cx="4928616" cy="914400"/>
+            <a:off x="4402836" y="2651760"/>
+            <a:ext cx="2848356" cy="914400"/>
           </a:xfrm>
           <a:prstGeom prst="rect">
             <a:avLst/>
@@ -23386,14 +23409,14 @@
       </p:sp>
       <p:sp>
         <p:nvSpPr>
-          <p:cNvPr id="11" name="lista"/>
+          <p:cNvPr id="12" name="lista"/>
           <p:cNvSpPr txBox="1"/>
           <p:nvPr/>
         </p:nvSpPr>
         <p:spPr>
           <a:xfrm>
-            <a:off x="6437376" y="3657600"/>
-            <a:ext cx="5020056" cy="2377440"/>
+            <a:off x="4357116" y="3657600"/>
+            <a:ext cx="2939796" cy="2377440"/>
           </a:xfrm>
           <a:prstGeom prst="rect">
             <a:avLst/>
@@ -23415,14 +23438,14 @@
               <a:buChar char="•"/>
             </a:pPr>
             <a:r>
-              <a:rPr lang="en-US" sz="2000" dirty="0">
+              <a:rPr lang="en-US" sz="1900" dirty="0">
                 <a:solidFill>
                   <a:srgbClr val="14142B"/>
                 </a:solidFill>
               </a:rPr>
               <a:t>Hola y chao, las dos cosas</a:t>
             </a:r>
-            <a:endParaRPr lang="en-US" sz="2000" dirty="0"/>
+            <a:endParaRPr lang="en-US" sz="1900" dirty="0"/>
           </a:p>
           <a:p>
             <a:pPr marL="228600" indent="-228600" eaLnBrk="1">
@@ -23433,14 +23456,14 @@
               <a:buChar char="•"/>
             </a:pPr>
             <a:r>
-              <a:rPr lang="en-US" sz="2000" dirty="0">
+              <a:rPr lang="en-US" sz="1900" dirty="0">
                 <a:solidFill>
                   <a:srgbClr val="14142B"/>
                 </a:solidFill>
               </a:rPr>
               <a:t>También a un niño o a alguien menor con confianza</a:t>
             </a:r>
-            <a:endParaRPr lang="en-US" sz="2000" dirty="0"/>
+            <a:endParaRPr lang="en-US" sz="1900" dirty="0"/>
           </a:p>
           <a:p>
             <a:pPr marL="228600" indent="-228600" eaLnBrk="1">
@@ -23451,14 +23474,14 @@
               <a:buChar char="•"/>
             </a:pPr>
             <a:r>
-              <a:rPr lang="en-US" sz="2000" dirty="0">
+              <a:rPr lang="en-US" sz="1900" dirty="0">
                 <a:solidFill>
                   <a:srgbClr val="14142B"/>
                 </a:solidFill>
               </a:rPr>
               <a:t>Con una persona mayor, no</a:t>
             </a:r>
-            <a:endParaRPr lang="en-US" sz="2000" dirty="0"/>
+            <a:endParaRPr lang="en-US" sz="1900" dirty="0"/>
           </a:p>
         </p:txBody>
       </p:sp>
@@ -23583,20 +23606,44 @@
           </a:p>
         </p:txBody>
       </p:sp>
-      <p:sp>
-        <p:nvSpPr>
-          <p:cNvPr id="3" name="col_0"/>
+      <p:pic>
+        <p:nvPicPr>
+          <p:cNvPr id="3" name="imagen" descr="C:\Users\Chingu\AppData\Local\Temp\claude\C--Users-Chingu-Desktop-ACADEMIASEULWEB\d4111e1b-5523-44ea-97b2-b1a1d9545b9e\scratchpad\decks\cache\img_ec5bc82628779a0a.png"/>
+          <p:cNvPicPr>
+            <a:picLocks noChangeAspect="1"/>
+          </p:cNvPicPr>
+          <p:nvPr/>
+        </p:nvPicPr>
+        <p:blipFill>
+          <a:blip r:embed="rId3"/>
+          <a:stretch>
+            <a:fillRect/>
+          </a:stretch>
+        </p:blipFill>
+        <p:spPr>
+          <a:xfrm>
+            <a:off x="8897112" y="2167666"/>
+            <a:ext cx="2743200" cy="3162748"/>
+          </a:xfrm>
+          <a:prstGeom prst="rect">
+            <a:avLst/>
+          </a:prstGeom>
+        </p:spPr>
+      </p:pic>
+      <p:sp>
+        <p:nvSpPr>
+          <p:cNvPr id="4" name="col_0"/>
           <p:cNvSpPr/>
           <p:nvPr/>
         </p:nvSpPr>
         <p:spPr>
           <a:xfrm>
             <a:off x="548640" y="1325880"/>
-            <a:ext cx="3483864" cy="4846320"/>
+            <a:ext cx="2478024" cy="4846320"/>
           </a:xfrm>
           <a:prstGeom prst="roundRect">
             <a:avLst>
-              <a:gd name="adj" fmla="val 3937"/>
+              <a:gd name="adj" fmla="val 5535"/>
             </a:avLst>
           </a:prstGeom>
           <a:solidFill>
@@ -23612,14 +23659,14 @@
       </p:sp>
       <p:sp>
         <p:nvSpPr>
-          <p:cNvPr id="4" name="Text 2"/>
+          <p:cNvPr id="5" name="Text 2"/>
           <p:cNvSpPr txBox="1"/>
           <p:nvPr/>
         </p:nvSpPr>
         <p:spPr>
           <a:xfrm>
             <a:off x="777240" y="1508760"/>
-            <a:ext cx="3026664" cy="548640"/>
+            <a:ext cx="2020824" cy="548640"/>
           </a:xfrm>
           <a:prstGeom prst="rect">
             <a:avLst/>
@@ -23650,14 +23697,14 @@
       </p:sp>
       <p:sp>
         <p:nvSpPr>
-          <p:cNvPr id="5" name="Text 3"/>
+          <p:cNvPr id="6" name="Text 3"/>
           <p:cNvSpPr txBox="1"/>
           <p:nvPr/>
         </p:nvSpPr>
         <p:spPr>
           <a:xfrm>
             <a:off x="777240" y="2103120"/>
-            <a:ext cx="3026664" cy="914400"/>
+            <a:ext cx="2020824" cy="914400"/>
           </a:xfrm>
           <a:prstGeom prst="rect">
             <a:avLst/>
@@ -23675,7 +23722,7 @@
               <a:buNone/>
             </a:pPr>
             <a:r>
-              <a:rPr lang="ko-KR" altLang="en-US" sz="3400" b="1" dirty="0">
+              <a:rPr lang="ko-KR" altLang="en-US" sz="2800" b="1" dirty="0">
                 <a:solidFill>
                   <a:srgbClr val="4236F6"/>
                 </a:solidFill>
@@ -23683,22 +23730,39 @@
                 <a:ea typeface="Malgun Gothic" pitchFamily="34" charset="-122"/>
                 <a:cs typeface="Malgun Gothic" pitchFamily="34" charset="-120"/>
               </a:rPr>
-              <a:t>안녕히 가세요</a:t>
-            </a:r>
-            <a:endParaRPr lang="en-US" sz="3400" dirty="0"/>
+              <a:t>안녕히</a:t>
+            </a:r>
+            <a:endParaRPr lang="en-US" sz="2800" dirty="0"/>
+          </a:p>
+          <a:p>
+            <a:pPr marL="0" indent="0" eaLnBrk="1">
+              <a:buNone/>
+            </a:pPr>
+            <a:r>
+              <a:rPr lang="ko-KR" altLang="en-US" sz="2800" b="1" dirty="0">
+                <a:solidFill>
+                  <a:srgbClr val="4236F6"/>
+                </a:solidFill>
+                <a:latin typeface="Malgun Gothic" pitchFamily="34" charset="0"/>
+                <a:ea typeface="Malgun Gothic" pitchFamily="34" charset="-122"/>
+                <a:cs typeface="Malgun Gothic" pitchFamily="34" charset="-120"/>
+              </a:rPr>
+              <a:t>가세요</a:t>
+            </a:r>
+            <a:endParaRPr lang="en-US" sz="2800" dirty="0"/>
           </a:p>
         </p:txBody>
       </p:sp>
       <p:sp>
         <p:nvSpPr>
-          <p:cNvPr id="6" name="lista"/>
+          <p:cNvPr id="7" name="lista"/>
           <p:cNvSpPr txBox="1"/>
           <p:nvPr/>
         </p:nvSpPr>
         <p:spPr>
           <a:xfrm>
             <a:off x="731520" y="3108960"/>
-            <a:ext cx="3118104" cy="2926080"/>
+            <a:ext cx="2112264" cy="2926080"/>
           </a:xfrm>
           <a:prstGeom prst="rect">
             <a:avLst/>
@@ -23762,18 +23826,18 @@
       </p:sp>
       <p:sp>
         <p:nvSpPr>
-          <p:cNvPr id="7" name="col_1"/>
+          <p:cNvPr id="8" name="col_1"/>
           <p:cNvSpPr/>
           <p:nvPr/>
         </p:nvSpPr>
         <p:spPr>
           <a:xfrm>
-            <a:off x="4352544" y="1325880"/>
-            <a:ext cx="3483864" cy="4846320"/>
+            <a:off x="3346704" y="1325880"/>
+            <a:ext cx="2478024" cy="4846320"/>
           </a:xfrm>
           <a:prstGeom prst="roundRect">
             <a:avLst>
-              <a:gd name="adj" fmla="val 3937"/>
+              <a:gd name="adj" fmla="val 5535"/>
             </a:avLst>
           </a:prstGeom>
           <a:solidFill>
@@ -23789,14 +23853,14 @@
       </p:sp>
       <p:sp>
         <p:nvSpPr>
-          <p:cNvPr id="8" name="Text 6"/>
+          <p:cNvPr id="9" name="Text 6"/>
           <p:cNvSpPr txBox="1"/>
           <p:nvPr/>
         </p:nvSpPr>
         <p:spPr>
           <a:xfrm>
-            <a:off x="4581144" y="1508760"/>
-            <a:ext cx="3026664" cy="548640"/>
+            <a:off x="3575304" y="1508760"/>
+            <a:ext cx="2020824" cy="548640"/>
           </a:xfrm>
           <a:prstGeom prst="rect">
             <a:avLst/>
@@ -23827,14 +23891,14 @@
       </p:sp>
       <p:sp>
         <p:nvSpPr>
-          <p:cNvPr id="9" name="Text 7"/>
+          <p:cNvPr id="10" name="Text 7"/>
           <p:cNvSpPr txBox="1"/>
           <p:nvPr/>
         </p:nvSpPr>
         <p:spPr>
           <a:xfrm>
-            <a:off x="4581144" y="2103120"/>
-            <a:ext cx="3026664" cy="914400"/>
+            <a:off x="3575304" y="2103120"/>
+            <a:ext cx="2020824" cy="914400"/>
           </a:xfrm>
           <a:prstGeom prst="rect">
             <a:avLst/>
@@ -23852,7 +23916,7 @@
               <a:buNone/>
             </a:pPr>
             <a:r>
-              <a:rPr lang="ko-KR" altLang="en-US" sz="3400" b="1" dirty="0">
+              <a:rPr lang="ko-KR" altLang="en-US" sz="2800" b="1" dirty="0">
                 <a:solidFill>
                   <a:srgbClr val="4236F6"/>
                 </a:solidFill>
@@ -23860,22 +23924,39 @@
                 <a:ea typeface="Malgun Gothic" pitchFamily="34" charset="-122"/>
                 <a:cs typeface="Malgun Gothic" pitchFamily="34" charset="-120"/>
               </a:rPr>
-              <a:t>안녕히 계세요</a:t>
-            </a:r>
-            <a:endParaRPr lang="en-US" sz="3400" dirty="0"/>
+              <a:t>안녕히</a:t>
+            </a:r>
+            <a:endParaRPr lang="en-US" sz="2800" dirty="0"/>
+          </a:p>
+          <a:p>
+            <a:pPr marL="0" indent="0" eaLnBrk="1">
+              <a:buNone/>
+            </a:pPr>
+            <a:r>
+              <a:rPr lang="ko-KR" altLang="en-US" sz="2800" b="1" dirty="0">
+                <a:solidFill>
+                  <a:srgbClr val="4236F6"/>
+                </a:solidFill>
+                <a:latin typeface="Malgun Gothic" pitchFamily="34" charset="0"/>
+                <a:ea typeface="Malgun Gothic" pitchFamily="34" charset="-122"/>
+                <a:cs typeface="Malgun Gothic" pitchFamily="34" charset="-120"/>
+              </a:rPr>
+              <a:t>계세요</a:t>
+            </a:r>
+            <a:endParaRPr lang="en-US" sz="2800" dirty="0"/>
           </a:p>
         </p:txBody>
       </p:sp>
       <p:sp>
         <p:nvSpPr>
-          <p:cNvPr id="10" name="lista"/>
+          <p:cNvPr id="11" name="lista"/>
           <p:cNvSpPr txBox="1"/>
           <p:nvPr/>
         </p:nvSpPr>
         <p:spPr>
           <a:xfrm>
-            <a:off x="4535424" y="3108960"/>
-            <a:ext cx="3118104" cy="2926080"/>
+            <a:off x="3529584" y="3108960"/>
+            <a:ext cx="2112264" cy="2926080"/>
           </a:xfrm>
           <a:prstGeom prst="rect">
             <a:avLst/>
@@ -23928,18 +24009,18 @@
       </p:sp>
       <p:sp>
         <p:nvSpPr>
-          <p:cNvPr id="11" name="col_2"/>
+          <p:cNvPr id="12" name="col_2"/>
           <p:cNvSpPr/>
           <p:nvPr/>
         </p:nvSpPr>
         <p:spPr>
           <a:xfrm>
-            <a:off x="8156448" y="1325880"/>
-            <a:ext cx="3483864" cy="4846320"/>
+            <a:off x="6144768" y="1325880"/>
+            <a:ext cx="2478024" cy="4846320"/>
           </a:xfrm>
           <a:prstGeom prst="roundRect">
             <a:avLst>
-              <a:gd name="adj" fmla="val 3937"/>
+              <a:gd name="adj" fmla="val 5535"/>
             </a:avLst>
           </a:prstGeom>
           <a:solidFill>
@@ -23955,14 +24036,14 @@
       </p:sp>
       <p:sp>
         <p:nvSpPr>
-          <p:cNvPr id="12" name="Text 10"/>
+          <p:cNvPr id="13" name="Text 10"/>
           <p:cNvSpPr txBox="1"/>
           <p:nvPr/>
         </p:nvSpPr>
         <p:spPr>
           <a:xfrm>
-            <a:off x="8385048" y="1508760"/>
-            <a:ext cx="3026664" cy="548640"/>
+            <a:off x="6373368" y="1508760"/>
+            <a:ext cx="2020824" cy="548640"/>
           </a:xfrm>
           <a:prstGeom prst="rect">
             <a:avLst/>
@@ -23993,14 +24074,14 @@
       </p:sp>
       <p:sp>
         <p:nvSpPr>
-          <p:cNvPr id="13" name="Text 11"/>
+          <p:cNvPr id="14" name="Text 11"/>
           <p:cNvSpPr txBox="1"/>
           <p:nvPr/>
         </p:nvSpPr>
         <p:spPr>
           <a:xfrm>
-            <a:off x="8385048" y="2103120"/>
-            <a:ext cx="3026664" cy="914400"/>
+            <a:off x="6373368" y="2103120"/>
+            <a:ext cx="2020824" cy="914400"/>
           </a:xfrm>
           <a:prstGeom prst="rect">
             <a:avLst/>
@@ -24018,7 +24099,7 @@
               <a:buNone/>
             </a:pPr>
             <a:r>
-              <a:rPr lang="ko-KR" altLang="en-US" sz="3400" b="1" dirty="0">
+              <a:rPr lang="ko-KR" altLang="en-US" sz="2800" b="1" dirty="0">
                 <a:solidFill>
                   <a:srgbClr val="4236F6"/>
                 </a:solidFill>
@@ -24026,22 +24107,39 @@
                 <a:ea typeface="Malgun Gothic" pitchFamily="34" charset="-122"/>
                 <a:cs typeface="Malgun Gothic" pitchFamily="34" charset="-120"/>
               </a:rPr>
-              <a:t>안녕히 가세요</a:t>
-            </a:r>
-            <a:endParaRPr lang="en-US" sz="3400" dirty="0"/>
+              <a:t>안녕히</a:t>
+            </a:r>
+            <a:endParaRPr lang="en-US" sz="2800" dirty="0"/>
+          </a:p>
+          <a:p>
+            <a:pPr marL="0" indent="0" eaLnBrk="1">
+              <a:buNone/>
+            </a:pPr>
+            <a:r>
+              <a:rPr lang="ko-KR" altLang="en-US" sz="2800" b="1" dirty="0">
+                <a:solidFill>
+                  <a:srgbClr val="4236F6"/>
+                </a:solidFill>
+                <a:latin typeface="Malgun Gothic" pitchFamily="34" charset="0"/>
+                <a:ea typeface="Malgun Gothic" pitchFamily="34" charset="-122"/>
+                <a:cs typeface="Malgun Gothic" pitchFamily="34" charset="-120"/>
+              </a:rPr>
+              <a:t>가세요</a:t>
+            </a:r>
+            <a:endParaRPr lang="en-US" sz="2800" dirty="0"/>
           </a:p>
         </p:txBody>
       </p:sp>
       <p:sp>
         <p:nvSpPr>
-          <p:cNvPr id="14" name="lista"/>
+          <p:cNvPr id="15" name="lista"/>
           <p:cNvSpPr txBox="1"/>
           <p:nvPr/>
         </p:nvSpPr>
         <p:spPr>
           <a:xfrm>
-            <a:off x="8339328" y="3108960"/>
-            <a:ext cx="3118104" cy="2926080"/>
+            <a:off x="6327648" y="3108960"/>
+            <a:ext cx="2112264" cy="2926080"/>
           </a:xfrm>
           <a:prstGeom prst="rect">
             <a:avLst/>
@@ -24225,7 +24323,7 @@
         <p:spPr>
           <a:xfrm>
             <a:off x="548640" y="1325880"/>
-            <a:ext cx="11064240" cy="457200"/>
+            <a:ext cx="11091672" cy="457200"/>
           </a:xfrm>
           <a:prstGeom prst="rect">
             <a:avLst/>
@@ -24331,7 +24429,7 @@
           <p:nvPr>
             <p:extLst>
               <p:ext uri="{D42A27DB-BD31-4B8C-83A1-F6EECF244321}">
-                <p14:modId xmlns:p14="http://schemas.microsoft.com/office/powerpoint/2010/main" val="3465321963"/>
+                <p14:modId xmlns:p14="http://schemas.microsoft.com/office/powerpoint/2010/main" val="3118914768"/>
               </p:ext>
             </p:extLst>
           </p:nvPr>
@@ -27197,7 +27295,7 @@
               <a:buChar char="•"/>
             </a:pPr>
             <a:r>
-              <a:rPr lang="ko-KR" altLang="en-US" sz="2400" dirty="0">
+              <a:rPr lang="ko-KR" altLang="en-US" sz="2800" dirty="0">
                 <a:solidFill>
                   <a:srgbClr val="14142B"/>
                 </a:solidFill>
@@ -27208,7 +27306,7 @@
               <a:t>안녕하세요</a:t>
             </a:r>
             <a:r>
-              <a:rPr lang="en-US" sz="2400" dirty="0">
+              <a:rPr lang="en-US" sz="2800" dirty="0">
                 <a:solidFill>
                   <a:srgbClr val="14142B"/>
                 </a:solidFill>
@@ -27216,7 +27314,7 @@
               <a:t>! </a:t>
             </a:r>
             <a:r>
-              <a:rPr lang="ko-KR" altLang="en-US" sz="2400" dirty="0">
+              <a:rPr lang="ko-KR" altLang="en-US" sz="2800" dirty="0">
                 <a:solidFill>
                   <a:srgbClr val="14142B"/>
                 </a:solidFill>
@@ -27227,7 +27325,7 @@
               <a:t>저는 </a:t>
             </a:r>
             <a:r>
-              <a:rPr lang="en-US" sz="2400" dirty="0">
+              <a:rPr lang="en-US" sz="2800" dirty="0">
                 <a:solidFill>
                   <a:srgbClr val="14142B"/>
                 </a:solidFill>
@@ -27235,7 +27333,7 @@
               <a:t>___</a:t>
             </a:r>
             <a:r>
-              <a:rPr lang="ko-KR" altLang="en-US" sz="2400" dirty="0">
+              <a:rPr lang="ko-KR" altLang="en-US" sz="2800" dirty="0">
                 <a:solidFill>
                   <a:srgbClr val="14142B"/>
                 </a:solidFill>
@@ -27246,7 +27344,7 @@
               <a:t>예요</a:t>
             </a:r>
             <a:r>
-              <a:rPr lang="en-US" sz="2400" dirty="0">
+              <a:rPr lang="en-US" sz="2800" dirty="0">
                 <a:solidFill>
                   <a:srgbClr val="14142B"/>
                 </a:solidFill>
@@ -27254,7 +27352,7 @@
               <a:t>/</a:t>
             </a:r>
             <a:r>
-              <a:rPr lang="ko-KR" altLang="en-US" sz="2400" dirty="0">
+              <a:rPr lang="ko-KR" altLang="en-US" sz="2800" dirty="0">
                 <a:solidFill>
                   <a:srgbClr val="14142B"/>
                 </a:solidFill>
@@ -27265,14 +27363,14 @@
               <a:t>이에요</a:t>
             </a:r>
             <a:r>
-              <a:rPr lang="en-US" sz="2400" dirty="0">
+              <a:rPr lang="en-US" sz="2800" dirty="0">
                 <a:solidFill>
                   <a:srgbClr val="14142B"/>
                 </a:solidFill>
               </a:rPr>
               <a:t>. (con tu nombre)</a:t>
             </a:r>
-            <a:endParaRPr lang="en-US" sz="2400" dirty="0"/>
+            <a:endParaRPr lang="en-US" sz="2800" dirty="0"/>
           </a:p>
           <a:p>
             <a:pPr marL="228600" indent="-228600" eaLnBrk="1">
@@ -27283,7 +27381,7 @@
               <a:buChar char="•"/>
             </a:pPr>
             <a:r>
-              <a:rPr lang="ko-KR" altLang="en-US" sz="2400" dirty="0">
+              <a:rPr lang="ko-KR" altLang="en-US" sz="2800" dirty="0">
                 <a:solidFill>
                   <a:srgbClr val="14142B"/>
                 </a:solidFill>
@@ -27294,14 +27392,14 @@
               <a:t>저는 칠레 사람이에요</a:t>
             </a:r>
             <a:r>
-              <a:rPr lang="en-US" sz="2400" dirty="0">
+              <a:rPr lang="en-US" sz="2800" dirty="0">
                 <a:solidFill>
                   <a:srgbClr val="14142B"/>
                 </a:solidFill>
               </a:rPr>
               <a:t>. (y después con tu país)</a:t>
             </a:r>
-            <a:endParaRPr lang="en-US" sz="2400" dirty="0"/>
+            <a:endParaRPr lang="en-US" sz="2800" dirty="0"/>
           </a:p>
           <a:p>
             <a:pPr marL="228600" indent="-228600" eaLnBrk="1">
@@ -27312,7 +27410,7 @@
               <a:buChar char="•"/>
             </a:pPr>
             <a:r>
-              <a:rPr lang="ko-KR" altLang="en-US" sz="2400" dirty="0">
+              <a:rPr lang="ko-KR" altLang="en-US" sz="2800" dirty="0">
                 <a:solidFill>
                   <a:srgbClr val="14142B"/>
                 </a:solidFill>
@@ -27323,14 +27421,14 @@
               <a:t>안녕히 계세요</a:t>
             </a:r>
             <a:r>
-              <a:rPr lang="en-US" sz="2400" dirty="0">
+              <a:rPr lang="en-US" sz="2800" dirty="0">
                 <a:solidFill>
                   <a:srgbClr val="14142B"/>
                 </a:solidFill>
               </a:rPr>
               <a:t>!</a:t>
             </a:r>
-            <a:endParaRPr lang="en-US" sz="2400" dirty="0"/>
+            <a:endParaRPr lang="en-US" sz="2800" dirty="0"/>
           </a:p>
         </p:txBody>
       </p:sp>
@@ -27526,7 +27624,7 @@
         <p:spPr>
           <a:xfrm>
             <a:off x="548640" y="1325880"/>
-            <a:ext cx="11064240" cy="457200"/>
+            <a:ext cx="11091672" cy="457200"/>
           </a:xfrm>
           <a:prstGeom prst="rect">
             <a:avLst/>
@@ -27564,7 +27662,7 @@
           <p:nvPr>
             <p:extLst>
               <p:ext uri="{D42A27DB-BD31-4B8C-83A1-F6EECF244321}">
-                <p14:modId xmlns:p14="http://schemas.microsoft.com/office/powerpoint/2010/main" val="2730013913"/>
+                <p14:modId xmlns:p14="http://schemas.microsoft.com/office/powerpoint/2010/main" val="1987320020"/>
               </p:ext>
             </p:extLst>
           </p:nvPr>
@@ -29445,16 +29543,40 @@
           </a:p>
         </p:txBody>
       </p:sp>
-      <p:sp>
-        <p:nvSpPr>
-          <p:cNvPr id="3" name="Text 1"/>
+      <p:pic>
+        <p:nvPicPr>
+          <p:cNvPr id="3" name="imagen" descr="C:\Users\Chingu\AppData\Local\Temp\claude\C--Users-Chingu-Desktop-ACADEMIASEULWEB\d4111e1b-5523-44ea-97b2-b1a1d9545b9e\scratchpad\decks\cache\img_ea43642194f546d8.png"/>
+          <p:cNvPicPr>
+            <a:picLocks noChangeAspect="1"/>
+          </p:cNvPicPr>
+          <p:nvPr/>
+        </p:nvPicPr>
+        <p:blipFill>
+          <a:blip r:embed="rId3"/>
+          <a:stretch>
+            <a:fillRect/>
+          </a:stretch>
+        </p:blipFill>
+        <p:spPr>
+          <a:xfrm>
+            <a:off x="7754112" y="1508760"/>
+            <a:ext cx="3886200" cy="4480560"/>
+          </a:xfrm>
+          <a:prstGeom prst="rect">
+            <a:avLst/>
+          </a:prstGeom>
+        </p:spPr>
+      </p:pic>
+      <p:sp>
+        <p:nvSpPr>
+          <p:cNvPr id="4" name="Text 1"/>
           <p:cNvSpPr txBox="1"/>
           <p:nvPr/>
         </p:nvSpPr>
         <p:spPr>
           <a:xfrm>
             <a:off x="548640" y="1325880"/>
-            <a:ext cx="11064240" cy="457200"/>
+            <a:ext cx="6931152" cy="457200"/>
           </a:xfrm>
           <a:prstGeom prst="rect">
             <a:avLst/>
@@ -29485,14 +29607,14 @@
       </p:sp>
       <p:sp>
         <p:nvSpPr>
-          <p:cNvPr id="4" name="tile_0"/>
+          <p:cNvPr id="5" name="tile_0"/>
           <p:cNvSpPr/>
           <p:nvPr/>
         </p:nvSpPr>
         <p:spPr>
           <a:xfrm>
             <a:off x="548640" y="1874520"/>
-            <a:ext cx="3544824" cy="2034540"/>
+            <a:ext cx="2157984" cy="2034540"/>
           </a:xfrm>
           <a:prstGeom prst="roundRect">
             <a:avLst>
@@ -29512,14 +29634,14 @@
       </p:sp>
       <p:sp>
         <p:nvSpPr>
-          <p:cNvPr id="5" name="Text 3"/>
+          <p:cNvPr id="6" name="Text 3"/>
           <p:cNvSpPr txBox="1"/>
           <p:nvPr/>
         </p:nvSpPr>
         <p:spPr>
           <a:xfrm>
             <a:off x="548640" y="1947672"/>
-            <a:ext cx="3544824" cy="1261415"/>
+            <a:ext cx="2157984" cy="1261415"/>
           </a:xfrm>
           <a:prstGeom prst="rect">
             <a:avLst/>
@@ -29537,7 +29659,7 @@
               <a:buNone/>
             </a:pPr>
             <a:r>
-              <a:rPr lang="ko-KR" altLang="en-US" sz="7600" b="1" dirty="0">
+              <a:rPr lang="ko-KR" altLang="en-US" sz="3600" b="1" dirty="0">
                 <a:solidFill>
                   <a:srgbClr val="4236F6"/>
                 </a:solidFill>
@@ -29547,20 +29669,20 @@
               </a:rPr>
               <a:t>김밥</a:t>
             </a:r>
-            <a:endParaRPr lang="en-US" sz="7600" dirty="0"/>
+            <a:endParaRPr lang="en-US" sz="3600" dirty="0"/>
           </a:p>
         </p:txBody>
       </p:sp>
       <p:sp>
         <p:nvSpPr>
-          <p:cNvPr id="6" name="tile_1"/>
+          <p:cNvPr id="7" name="tile_1"/>
           <p:cNvSpPr/>
           <p:nvPr/>
         </p:nvSpPr>
         <p:spPr>
           <a:xfrm>
-            <a:off x="4322064" y="1874520"/>
-            <a:ext cx="3544824" cy="2034540"/>
+            <a:off x="2935224" y="1874520"/>
+            <a:ext cx="2157984" cy="2034540"/>
           </a:xfrm>
           <a:prstGeom prst="roundRect">
             <a:avLst>
@@ -29580,14 +29702,14 @@
       </p:sp>
       <p:sp>
         <p:nvSpPr>
-          <p:cNvPr id="7" name="Text 5"/>
+          <p:cNvPr id="8" name="Text 5"/>
           <p:cNvSpPr txBox="1"/>
           <p:nvPr/>
         </p:nvSpPr>
         <p:spPr>
           <a:xfrm>
-            <a:off x="4322064" y="1947672"/>
-            <a:ext cx="3544824" cy="1261415"/>
+            <a:off x="2935224" y="1947672"/>
+            <a:ext cx="2157984" cy="1261415"/>
           </a:xfrm>
           <a:prstGeom prst="rect">
             <a:avLst/>
@@ -29605,7 +29727,7 @@
               <a:buNone/>
             </a:pPr>
             <a:r>
-              <a:rPr lang="ko-KR" altLang="en-US" sz="7600" b="1" dirty="0">
+              <a:rPr lang="ko-KR" altLang="en-US" sz="3600" b="1" dirty="0">
                 <a:solidFill>
                   <a:srgbClr val="4236F6"/>
                 </a:solidFill>
@@ -29615,20 +29737,20 @@
               </a:rPr>
               <a:t>비빔밥</a:t>
             </a:r>
-            <a:endParaRPr lang="en-US" sz="7600" dirty="0"/>
+            <a:endParaRPr lang="en-US" sz="3600" dirty="0"/>
           </a:p>
         </p:txBody>
       </p:sp>
       <p:sp>
         <p:nvSpPr>
-          <p:cNvPr id="8" name="tile_2"/>
+          <p:cNvPr id="9" name="tile_2"/>
           <p:cNvSpPr/>
           <p:nvPr/>
         </p:nvSpPr>
         <p:spPr>
           <a:xfrm>
-            <a:off x="8095488" y="1874520"/>
-            <a:ext cx="3544824" cy="2034540"/>
+            <a:off x="5321808" y="1874520"/>
+            <a:ext cx="2157984" cy="2034540"/>
           </a:xfrm>
           <a:prstGeom prst="roundRect">
             <a:avLst>
@@ -29648,14 +29770,14 @@
       </p:sp>
       <p:sp>
         <p:nvSpPr>
-          <p:cNvPr id="9" name="Text 7"/>
+          <p:cNvPr id="10" name="Text 7"/>
           <p:cNvSpPr txBox="1"/>
           <p:nvPr/>
         </p:nvSpPr>
         <p:spPr>
           <a:xfrm>
-            <a:off x="8095488" y="1947672"/>
-            <a:ext cx="3544824" cy="1261415"/>
+            <a:off x="5321808" y="1947672"/>
+            <a:ext cx="2157984" cy="1261415"/>
           </a:xfrm>
           <a:prstGeom prst="rect">
             <a:avLst/>
@@ -29673,7 +29795,7 @@
               <a:buNone/>
             </a:pPr>
             <a:r>
-              <a:rPr lang="ko-KR" altLang="en-US" sz="7600" b="1" dirty="0">
+              <a:rPr lang="ko-KR" altLang="en-US" sz="3600" b="1" dirty="0">
                 <a:solidFill>
                   <a:srgbClr val="4236F6"/>
                 </a:solidFill>
@@ -29683,20 +29805,20 @@
               </a:rPr>
               <a:t>불고기</a:t>
             </a:r>
-            <a:endParaRPr lang="en-US" sz="7600" dirty="0"/>
+            <a:endParaRPr lang="en-US" sz="3600" dirty="0"/>
           </a:p>
         </p:txBody>
       </p:sp>
       <p:sp>
         <p:nvSpPr>
-          <p:cNvPr id="10" name="tile_3"/>
+          <p:cNvPr id="11" name="tile_3"/>
           <p:cNvSpPr/>
           <p:nvPr/>
         </p:nvSpPr>
         <p:spPr>
           <a:xfrm>
             <a:off x="548640" y="4137660"/>
-            <a:ext cx="3544824" cy="2034540"/>
+            <a:ext cx="2157984" cy="2034540"/>
           </a:xfrm>
           <a:prstGeom prst="roundRect">
             <a:avLst>
@@ -29716,14 +29838,14 @@
       </p:sp>
       <p:sp>
         <p:nvSpPr>
-          <p:cNvPr id="11" name="Text 9"/>
+          <p:cNvPr id="12" name="Text 9"/>
           <p:cNvSpPr txBox="1"/>
           <p:nvPr/>
         </p:nvSpPr>
         <p:spPr>
           <a:xfrm>
             <a:off x="548640" y="4210812"/>
-            <a:ext cx="3544824" cy="1261415"/>
+            <a:ext cx="2157984" cy="1261415"/>
           </a:xfrm>
           <a:prstGeom prst="rect">
             <a:avLst/>
@@ -29741,7 +29863,7 @@
               <a:buNone/>
             </a:pPr>
             <a:r>
-              <a:rPr lang="ko-KR" altLang="en-US" sz="7600" b="1" dirty="0">
+              <a:rPr lang="ko-KR" altLang="en-US" sz="3600" b="1" dirty="0">
                 <a:solidFill>
                   <a:srgbClr val="4236F6"/>
                 </a:solidFill>
@@ -29751,20 +29873,20 @@
               </a:rPr>
               <a:t>라면</a:t>
             </a:r>
-            <a:endParaRPr lang="en-US" sz="7600" dirty="0"/>
+            <a:endParaRPr lang="en-US" sz="3600" dirty="0"/>
           </a:p>
         </p:txBody>
       </p:sp>
       <p:sp>
         <p:nvSpPr>
-          <p:cNvPr id="12" name="tile_4"/>
+          <p:cNvPr id="13" name="tile_4"/>
           <p:cNvSpPr/>
           <p:nvPr/>
         </p:nvSpPr>
         <p:spPr>
           <a:xfrm>
-            <a:off x="4322064" y="4137660"/>
-            <a:ext cx="3544824" cy="2034540"/>
+            <a:off x="2935224" y="4137660"/>
+            <a:ext cx="2157984" cy="2034540"/>
           </a:xfrm>
           <a:prstGeom prst="roundRect">
             <a:avLst>
@@ -29784,14 +29906,14 @@
       </p:sp>
       <p:sp>
         <p:nvSpPr>
-          <p:cNvPr id="13" name="Text 11"/>
+          <p:cNvPr id="14" name="Text 11"/>
           <p:cNvSpPr txBox="1"/>
           <p:nvPr/>
         </p:nvSpPr>
         <p:spPr>
           <a:xfrm>
-            <a:off x="4322064" y="4210812"/>
-            <a:ext cx="3544824" cy="1261415"/>
+            <a:off x="2935224" y="4210812"/>
+            <a:ext cx="2157984" cy="1261415"/>
           </a:xfrm>
           <a:prstGeom prst="rect">
             <a:avLst/>
@@ -29809,7 +29931,7 @@
               <a:buNone/>
             </a:pPr>
             <a:r>
-              <a:rPr lang="ko-KR" altLang="en-US" sz="6100" b="1" dirty="0">
+              <a:rPr lang="ko-KR" altLang="en-US" sz="3600" b="1" dirty="0">
                 <a:solidFill>
                   <a:srgbClr val="4236F6"/>
                 </a:solidFill>
@@ -29819,7 +29941,7 @@
               </a:rPr>
               <a:t>김치찌개</a:t>
             </a:r>
-            <a:endParaRPr lang="en-US" sz="6100" dirty="0"/>
+            <a:endParaRPr lang="en-US" sz="3600" dirty="0"/>
           </a:p>
         </p:txBody>
       </p:sp>
@@ -30013,7 +30135,7 @@
               <a:buChar char="•"/>
             </a:pPr>
             <a:r>
-              <a:rPr lang="ko-KR" altLang="en-US" sz="2400" dirty="0">
+              <a:rPr lang="ko-KR" altLang="en-US" sz="2800" dirty="0">
                 <a:solidFill>
                   <a:srgbClr val="14142B"/>
                 </a:solidFill>
@@ -30024,7 +30146,7 @@
               <a:t>안녕하세요</a:t>
             </a:r>
             <a:r>
-              <a:rPr lang="en-US" sz="2400" dirty="0">
+              <a:rPr lang="en-US" sz="2800" dirty="0">
                 <a:solidFill>
                   <a:srgbClr val="14142B"/>
                 </a:solidFill>
@@ -30032,7 +30154,7 @@
               <a:t>! </a:t>
             </a:r>
             <a:r>
-              <a:rPr lang="ko-KR" altLang="en-US" sz="2400" dirty="0">
+              <a:rPr lang="ko-KR" altLang="en-US" sz="2800" dirty="0">
                 <a:solidFill>
                   <a:srgbClr val="14142B"/>
                 </a:solidFill>
@@ -30043,7 +30165,7 @@
               <a:t>저는 </a:t>
             </a:r>
             <a:r>
-              <a:rPr lang="en-US" sz="2400" dirty="0">
+              <a:rPr lang="en-US" sz="2800" dirty="0">
                 <a:solidFill>
                   <a:srgbClr val="14142B"/>
                 </a:solidFill>
@@ -30051,7 +30173,7 @@
               <a:t>___</a:t>
             </a:r>
             <a:r>
-              <a:rPr lang="ko-KR" altLang="en-US" sz="2400" dirty="0">
+              <a:rPr lang="ko-KR" altLang="en-US" sz="2800" dirty="0">
                 <a:solidFill>
                   <a:srgbClr val="14142B"/>
                 </a:solidFill>
@@ -30062,7 +30184,7 @@
               <a:t>예요</a:t>
             </a:r>
             <a:r>
-              <a:rPr lang="en-US" sz="2400" dirty="0">
+              <a:rPr lang="en-US" sz="2800" dirty="0">
                 <a:solidFill>
                   <a:srgbClr val="14142B"/>
                 </a:solidFill>
@@ -30070,7 +30192,7 @@
               <a:t>/</a:t>
             </a:r>
             <a:r>
-              <a:rPr lang="ko-KR" altLang="en-US" sz="2400" dirty="0">
+              <a:rPr lang="ko-KR" altLang="en-US" sz="2800" dirty="0">
                 <a:solidFill>
                   <a:srgbClr val="14142B"/>
                 </a:solidFill>
@@ -30081,14 +30203,14 @@
               <a:t>이에요</a:t>
             </a:r>
             <a:r>
-              <a:rPr lang="en-US" sz="2400" dirty="0">
+              <a:rPr lang="en-US" sz="2800" dirty="0">
                 <a:solidFill>
                   <a:srgbClr val="14142B"/>
                 </a:solidFill>
               </a:rPr>
               <a:t>. — ¡Hola! Soy ___.</a:t>
             </a:r>
-            <a:endParaRPr lang="en-US" sz="2400" dirty="0"/>
+            <a:endParaRPr lang="en-US" sz="2800" dirty="0"/>
           </a:p>
           <a:p>
             <a:pPr marL="228600" indent="-228600" eaLnBrk="1">
@@ -30099,7 +30221,7 @@
               <a:buChar char="•"/>
             </a:pPr>
             <a:r>
-              <a:rPr lang="ko-KR" altLang="en-US" sz="2400" dirty="0">
+              <a:rPr lang="ko-KR" altLang="en-US" sz="2800" dirty="0">
                 <a:solidFill>
                   <a:srgbClr val="14142B"/>
                 </a:solidFill>
@@ -30110,14 +30232,14 @@
               <a:t>저는 칠레 사람이에요</a:t>
             </a:r>
             <a:r>
-              <a:rPr lang="en-US" sz="2400" dirty="0">
+              <a:rPr lang="en-US" sz="2800" dirty="0">
                 <a:solidFill>
                   <a:srgbClr val="14142B"/>
                 </a:solidFill>
               </a:rPr>
               <a:t>. — Soy chileno, chilena.</a:t>
             </a:r>
-            <a:endParaRPr lang="en-US" sz="2400" dirty="0"/>
+            <a:endParaRPr lang="en-US" sz="2800" dirty="0"/>
           </a:p>
           <a:p>
             <a:pPr marL="228600" indent="-228600" eaLnBrk="1">
@@ -30128,7 +30250,7 @@
               <a:buChar char="•"/>
             </a:pPr>
             <a:r>
-              <a:rPr lang="ko-KR" altLang="en-US" sz="2400" dirty="0">
+              <a:rPr lang="ko-KR" altLang="en-US" sz="2800" dirty="0">
                 <a:solidFill>
                   <a:srgbClr val="14142B"/>
                 </a:solidFill>
@@ -30139,14 +30261,14 @@
               <a:t>안녕히 계세요</a:t>
             </a:r>
             <a:r>
-              <a:rPr lang="en-US" sz="2400" dirty="0">
+              <a:rPr lang="en-US" sz="2800" dirty="0">
                 <a:solidFill>
                   <a:srgbClr val="14142B"/>
                 </a:solidFill>
               </a:rPr>
               <a:t>! — Adiós (a quien se queda).</a:t>
             </a:r>
-            <a:endParaRPr lang="en-US" sz="2400" dirty="0"/>
+            <a:endParaRPr lang="en-US" sz="2800" dirty="0"/>
           </a:p>
         </p:txBody>
       </p:sp>
@@ -30333,16 +30455,40 @@
           </a:p>
         </p:txBody>
       </p:sp>
-      <p:sp>
-        <p:nvSpPr>
-          <p:cNvPr id="3" name="Text 1"/>
+      <p:pic>
+        <p:nvPicPr>
+          <p:cNvPr id="3" name="imagen" descr="C:\Users\Chingu\AppData\Local\Temp\claude\C--Users-Chingu-Desktop-ACADEMIASEULWEB\d4111e1b-5523-44ea-97b2-b1a1d9545b9e\scratchpad\decks\cache\img_b75a909edb1c3ccc.png"/>
+          <p:cNvPicPr>
+            <a:picLocks noChangeAspect="1"/>
+          </p:cNvPicPr>
+          <p:nvPr/>
+        </p:nvPicPr>
+        <p:blipFill>
+          <a:blip r:embed="rId3"/>
+          <a:stretch>
+            <a:fillRect/>
+          </a:stretch>
+        </p:blipFill>
+        <p:spPr>
+          <a:xfrm>
+            <a:off x="7754112" y="1508760"/>
+            <a:ext cx="3886200" cy="4480560"/>
+          </a:xfrm>
+          <a:prstGeom prst="rect">
+            <a:avLst/>
+          </a:prstGeom>
+        </p:spPr>
+      </p:pic>
+      <p:sp>
+        <p:nvSpPr>
+          <p:cNvPr id="4" name="Text 1"/>
           <p:cNvSpPr txBox="1"/>
           <p:nvPr/>
         </p:nvSpPr>
         <p:spPr>
           <a:xfrm>
             <a:off x="548640" y="1325880"/>
-            <a:ext cx="11064240" cy="457200"/>
+            <a:ext cx="6931152" cy="457200"/>
           </a:xfrm>
           <a:prstGeom prst="rect">
             <a:avLst/>
@@ -30384,14 +30530,14 @@
       </p:sp>
       <p:sp>
         <p:nvSpPr>
-          <p:cNvPr id="4" name="tile_0"/>
+          <p:cNvPr id="5" name="tile_0"/>
           <p:cNvSpPr/>
           <p:nvPr/>
         </p:nvSpPr>
         <p:spPr>
           <a:xfrm>
             <a:off x="548640" y="1874520"/>
-            <a:ext cx="3544824" cy="2034540"/>
+            <a:ext cx="2157984" cy="2034540"/>
           </a:xfrm>
           <a:prstGeom prst="roundRect">
             <a:avLst>
@@ -30411,14 +30557,14 @@
       </p:sp>
       <p:sp>
         <p:nvSpPr>
-          <p:cNvPr id="5" name="Text 3"/>
+          <p:cNvPr id="6" name="Text 3"/>
           <p:cNvSpPr txBox="1"/>
           <p:nvPr/>
         </p:nvSpPr>
         <p:spPr>
           <a:xfrm>
             <a:off x="548640" y="1947672"/>
-            <a:ext cx="3544824" cy="1261415"/>
+            <a:ext cx="2157984" cy="1261415"/>
           </a:xfrm>
           <a:prstGeom prst="rect">
             <a:avLst/>
@@ -30436,7 +30582,7 @@
               <a:buNone/>
             </a:pPr>
             <a:r>
-              <a:rPr lang="ko-KR" altLang="en-US" sz="7600" b="1" dirty="0">
+              <a:rPr lang="ko-KR" altLang="en-US" sz="7300" b="1" dirty="0">
                 <a:solidFill>
                   <a:srgbClr val="4236F6"/>
                 </a:solidFill>
@@ -30446,20 +30592,20 @@
               </a:rPr>
               <a:t>가</a:t>
             </a:r>
-            <a:endParaRPr lang="en-US" sz="7600" dirty="0"/>
+            <a:endParaRPr lang="en-US" sz="7300" dirty="0"/>
           </a:p>
         </p:txBody>
       </p:sp>
       <p:sp>
         <p:nvSpPr>
-          <p:cNvPr id="6" name="Text 4"/>
+          <p:cNvPr id="7" name="Text 4"/>
           <p:cNvSpPr txBox="1"/>
           <p:nvPr/>
         </p:nvSpPr>
         <p:spPr>
           <a:xfrm>
             <a:off x="594360" y="3176626"/>
-            <a:ext cx="3453384" cy="695858"/>
+            <a:ext cx="2066544" cy="695858"/>
           </a:xfrm>
           <a:prstGeom prst="rect">
             <a:avLst/>
@@ -30490,14 +30636,14 @@
       </p:sp>
       <p:sp>
         <p:nvSpPr>
-          <p:cNvPr id="7" name="tile_1"/>
+          <p:cNvPr id="8" name="tile_1"/>
           <p:cNvSpPr/>
           <p:nvPr/>
         </p:nvSpPr>
         <p:spPr>
           <a:xfrm>
-            <a:off x="4322064" y="1874520"/>
-            <a:ext cx="3544824" cy="2034540"/>
+            <a:off x="2935224" y="1874520"/>
+            <a:ext cx="2157984" cy="2034540"/>
           </a:xfrm>
           <a:prstGeom prst="roundRect">
             <a:avLst>
@@ -30517,14 +30663,14 @@
       </p:sp>
       <p:sp>
         <p:nvSpPr>
-          <p:cNvPr id="8" name="Text 6"/>
+          <p:cNvPr id="9" name="Text 6"/>
           <p:cNvSpPr txBox="1"/>
           <p:nvPr/>
         </p:nvSpPr>
         <p:spPr>
           <a:xfrm>
-            <a:off x="4322064" y="1947672"/>
-            <a:ext cx="3544824" cy="1261415"/>
+            <a:off x="2935224" y="1947672"/>
+            <a:ext cx="2157984" cy="1261415"/>
           </a:xfrm>
           <a:prstGeom prst="rect">
             <a:avLst/>
@@ -30542,7 +30688,7 @@
               <a:buNone/>
             </a:pPr>
             <a:r>
-              <a:rPr lang="ko-KR" altLang="en-US" sz="7600" b="1" dirty="0">
+              <a:rPr lang="ko-KR" altLang="en-US" sz="7300" b="1" dirty="0">
                 <a:solidFill>
                   <a:srgbClr val="4236F6"/>
                 </a:solidFill>
@@ -30552,20 +30698,20 @@
               </a:rPr>
               <a:t>강</a:t>
             </a:r>
-            <a:endParaRPr lang="en-US" sz="7600" dirty="0"/>
+            <a:endParaRPr lang="en-US" sz="7300" dirty="0"/>
           </a:p>
         </p:txBody>
       </p:sp>
       <p:sp>
         <p:nvSpPr>
-          <p:cNvPr id="9" name="Text 7"/>
+          <p:cNvPr id="10" name="Text 7"/>
           <p:cNvSpPr txBox="1"/>
           <p:nvPr/>
         </p:nvSpPr>
         <p:spPr>
           <a:xfrm>
-            <a:off x="4367784" y="3176626"/>
-            <a:ext cx="3453384" cy="695858"/>
+            <a:off x="2980944" y="3176626"/>
+            <a:ext cx="2066544" cy="695858"/>
           </a:xfrm>
           <a:prstGeom prst="rect">
             <a:avLst/>
@@ -30626,14 +30772,14 @@
       </p:sp>
       <p:sp>
         <p:nvSpPr>
-          <p:cNvPr id="10" name="tile_2"/>
+          <p:cNvPr id="11" name="tile_2"/>
           <p:cNvSpPr/>
           <p:nvPr/>
         </p:nvSpPr>
         <p:spPr>
           <a:xfrm>
-            <a:off x="8095488" y="1874520"/>
-            <a:ext cx="3544824" cy="2034540"/>
+            <a:off x="5321808" y="1874520"/>
+            <a:ext cx="2157984" cy="2034540"/>
           </a:xfrm>
           <a:prstGeom prst="roundRect">
             <a:avLst>
@@ -30653,14 +30799,14 @@
       </p:sp>
       <p:sp>
         <p:nvSpPr>
-          <p:cNvPr id="11" name="Text 9"/>
+          <p:cNvPr id="12" name="Text 9"/>
           <p:cNvSpPr txBox="1"/>
           <p:nvPr/>
         </p:nvSpPr>
         <p:spPr>
           <a:xfrm>
-            <a:off x="8095488" y="1947672"/>
-            <a:ext cx="3544824" cy="1261415"/>
+            <a:off x="5321808" y="1947672"/>
+            <a:ext cx="2157984" cy="1261415"/>
           </a:xfrm>
           <a:prstGeom prst="rect">
             <a:avLst/>
@@ -30678,7 +30824,7 @@
               <a:buNone/>
             </a:pPr>
             <a:r>
-              <a:rPr lang="ko-KR" altLang="en-US" sz="7600" b="1" dirty="0">
+              <a:rPr lang="ko-KR" altLang="en-US" sz="7300" b="1" dirty="0">
                 <a:solidFill>
                   <a:srgbClr val="4236F6"/>
                 </a:solidFill>
@@ -30688,20 +30834,20 @@
               </a:rPr>
               <a:t>바</a:t>
             </a:r>
-            <a:endParaRPr lang="en-US" sz="7600" dirty="0"/>
+            <a:endParaRPr lang="en-US" sz="7300" dirty="0"/>
           </a:p>
         </p:txBody>
       </p:sp>
       <p:sp>
         <p:nvSpPr>
-          <p:cNvPr id="12" name="Text 10"/>
+          <p:cNvPr id="13" name="Text 10"/>
           <p:cNvSpPr txBox="1"/>
           <p:nvPr/>
         </p:nvSpPr>
         <p:spPr>
           <a:xfrm>
-            <a:off x="8141208" y="3176626"/>
-            <a:ext cx="3453384" cy="695858"/>
+            <a:off x="5367528" y="3176626"/>
+            <a:ext cx="2066544" cy="695858"/>
           </a:xfrm>
           <a:prstGeom prst="rect">
             <a:avLst/>
@@ -30732,14 +30878,14 @@
       </p:sp>
       <p:sp>
         <p:nvSpPr>
-          <p:cNvPr id="13" name="tile_3"/>
+          <p:cNvPr id="14" name="tile_3"/>
           <p:cNvSpPr/>
           <p:nvPr/>
         </p:nvSpPr>
         <p:spPr>
           <a:xfrm>
             <a:off x="548640" y="4137660"/>
-            <a:ext cx="3544824" cy="2034540"/>
+            <a:ext cx="2157984" cy="2034540"/>
           </a:xfrm>
           <a:prstGeom prst="roundRect">
             <a:avLst>
@@ -30759,14 +30905,14 @@
       </p:sp>
       <p:sp>
         <p:nvSpPr>
-          <p:cNvPr id="14" name="Text 12"/>
+          <p:cNvPr id="15" name="Text 12"/>
           <p:cNvSpPr txBox="1"/>
           <p:nvPr/>
         </p:nvSpPr>
         <p:spPr>
           <a:xfrm>
             <a:off x="548640" y="4210812"/>
-            <a:ext cx="3544824" cy="1261415"/>
+            <a:ext cx="2157984" cy="1261415"/>
           </a:xfrm>
           <a:prstGeom prst="rect">
             <a:avLst/>
@@ -30784,7 +30930,7 @@
               <a:buNone/>
             </a:pPr>
             <a:r>
-              <a:rPr lang="ko-KR" altLang="en-US" sz="7600" b="1" dirty="0">
+              <a:rPr lang="ko-KR" altLang="en-US" sz="7300" b="1" dirty="0">
                 <a:solidFill>
                   <a:srgbClr val="4236F6"/>
                 </a:solidFill>
@@ -30794,20 +30940,20 @@
               </a:rPr>
               <a:t>밥</a:t>
             </a:r>
-            <a:endParaRPr lang="en-US" sz="7600" dirty="0"/>
+            <a:endParaRPr lang="en-US" sz="7300" dirty="0"/>
           </a:p>
         </p:txBody>
       </p:sp>
       <p:sp>
         <p:nvSpPr>
-          <p:cNvPr id="15" name="Text 13"/>
+          <p:cNvPr id="16" name="Text 13"/>
           <p:cNvSpPr txBox="1"/>
           <p:nvPr/>
         </p:nvSpPr>
         <p:spPr>
           <a:xfrm>
             <a:off x="594360" y="5439766"/>
-            <a:ext cx="3453384" cy="695858"/>
+            <a:ext cx="2066544" cy="695858"/>
           </a:xfrm>
           <a:prstGeom prst="rect">
             <a:avLst/>
@@ -30868,14 +31014,14 @@
       </p:sp>
       <p:sp>
         <p:nvSpPr>
-          <p:cNvPr id="16" name="tile_4"/>
+          <p:cNvPr id="17" name="tile_4"/>
           <p:cNvSpPr/>
           <p:nvPr/>
         </p:nvSpPr>
         <p:spPr>
           <a:xfrm>
-            <a:off x="4322064" y="4137660"/>
-            <a:ext cx="3544824" cy="2034540"/>
+            <a:off x="2935224" y="4137660"/>
+            <a:ext cx="2157984" cy="2034540"/>
           </a:xfrm>
           <a:prstGeom prst="roundRect">
             <a:avLst>
@@ -30895,14 +31041,14 @@
       </p:sp>
       <p:sp>
         <p:nvSpPr>
-          <p:cNvPr id="17" name="Text 15"/>
+          <p:cNvPr id="18" name="Text 15"/>
           <p:cNvSpPr txBox="1"/>
           <p:nvPr/>
         </p:nvSpPr>
         <p:spPr>
           <a:xfrm>
-            <a:off x="4322064" y="4210812"/>
-            <a:ext cx="3544824" cy="1261415"/>
+            <a:off x="2935224" y="4210812"/>
+            <a:ext cx="2157984" cy="1261415"/>
           </a:xfrm>
           <a:prstGeom prst="rect">
             <a:avLst/>
@@ -30920,7 +31066,7 @@
               <a:buNone/>
             </a:pPr>
             <a:r>
-              <a:rPr lang="ko-KR" altLang="en-US" sz="7600" b="1" dirty="0">
+              <a:rPr lang="ko-KR" altLang="en-US" sz="7300" b="1" dirty="0">
                 <a:solidFill>
                   <a:srgbClr val="4236F6"/>
                 </a:solidFill>
@@ -30930,20 +31076,20 @@
               </a:rPr>
               <a:t>한국</a:t>
             </a:r>
-            <a:endParaRPr lang="en-US" sz="7600" dirty="0"/>
+            <a:endParaRPr lang="en-US" sz="7300" dirty="0"/>
           </a:p>
         </p:txBody>
       </p:sp>
       <p:sp>
         <p:nvSpPr>
-          <p:cNvPr id="18" name="Text 16"/>
+          <p:cNvPr id="19" name="Text 16"/>
           <p:cNvSpPr txBox="1"/>
           <p:nvPr/>
         </p:nvSpPr>
         <p:spPr>
           <a:xfrm>
-            <a:off x="4367784" y="5439766"/>
-            <a:ext cx="3453384" cy="695858"/>
+            <a:off x="2980944" y="5439766"/>
+            <a:ext cx="2066544" cy="695858"/>
           </a:xfrm>
           <a:prstGeom prst="rect">
             <a:avLst/>
@@ -31124,7 +31270,7 @@
         <p:spPr>
           <a:xfrm>
             <a:off x="548640" y="1325880"/>
-            <a:ext cx="11064240" cy="457200"/>
+            <a:ext cx="11091672" cy="457200"/>
           </a:xfrm>
           <a:prstGeom prst="rect">
             <a:avLst/>
@@ -31162,7 +31308,7 @@
           <p:nvPr>
             <p:extLst>
               <p:ext uri="{D42A27DB-BD31-4B8C-83A1-F6EECF244321}">
-                <p14:modId xmlns:p14="http://schemas.microsoft.com/office/powerpoint/2010/main" val="2878765782"/>
+                <p14:modId xmlns:p14="http://schemas.microsoft.com/office/powerpoint/2010/main" val="2832896955"/>
               </p:ext>
             </p:extLst>
           </p:nvPr>
@@ -31467,7 +31613,7 @@
                           <a:ea typeface="Malgun Gothic" pitchFamily="34" charset="-122"/>
                           <a:cs typeface="Malgun Gothic" pitchFamily="34" charset="-120"/>
                         </a:rPr>
-                        <a:t>ㄱ ㅋ ㄲ</a:t>
+                        <a:t>ㄱ ㅋ ㄲ</a:t>
                       </a:r>
                       <a:endParaRPr lang="en-US" sz="1200" dirty="0"/>
                     </a:p>
@@ -31859,7 +32005,7 @@
                           <a:ea typeface="Malgun Gothic" pitchFamily="34" charset="-122"/>
                           <a:cs typeface="Malgun Gothic" pitchFamily="34" charset="-120"/>
                         </a:rPr>
-                        <a:t>ㄷ ㅅ ㅆ ㅈ ㅊ ㅌ ㅎ</a:t>
+                        <a:t>ㄷ ㅅ ㅆ ㅈ ㅊ ㅌ ㅎ</a:t>
                       </a:r>
                       <a:endParaRPr lang="en-US" sz="1200" dirty="0"/>
                     </a:p>
@@ -32447,7 +32593,7 @@
                           <a:ea typeface="Malgun Gothic" pitchFamily="34" charset="-122"/>
                           <a:cs typeface="Malgun Gothic" pitchFamily="34" charset="-120"/>
                         </a:rPr>
-                        <a:t>ㅂ ㅍ</a:t>
+                        <a:t>ㅂ ㅍ</a:t>
                       </a:r>
                       <a:endParaRPr lang="en-US" sz="1200" dirty="0"/>
                     </a:p>
@@ -32938,8 +33084,8 @@
         </p:blipFill>
         <p:spPr>
           <a:xfrm>
-            <a:off x="1364513" y="1435608"/>
-            <a:ext cx="969721" cy="969721"/>
+            <a:off x="1295248" y="1435608"/>
+            <a:ext cx="1108253" cy="1108253"/>
           </a:xfrm>
           <a:prstGeom prst="rect">
             <a:avLst/>
@@ -32954,8 +33100,8 @@
         </p:nvSpPr>
         <p:spPr>
           <a:xfrm>
-            <a:off x="548640" y="2423617"/>
-            <a:ext cx="2601468" cy="507949"/>
+            <a:off x="548640" y="2562149"/>
+            <a:ext cx="2601468" cy="461772"/>
           </a:xfrm>
           <a:prstGeom prst="rect">
             <a:avLst/>
@@ -32973,7 +33119,7 @@
               <a:buNone/>
             </a:pPr>
             <a:r>
-              <a:rPr lang="ko-KR" altLang="en-US" sz="3100" b="1" dirty="0">
+              <a:rPr lang="ko-KR" altLang="en-US" sz="2900" b="1" dirty="0">
                 <a:solidFill>
                   <a:srgbClr val="4236F6"/>
                 </a:solidFill>
@@ -32983,7 +33129,7 @@
               </a:rPr>
               <a:t>한국</a:t>
             </a:r>
-            <a:endParaRPr lang="en-US" sz="3100" dirty="0"/>
+            <a:endParaRPr lang="en-US" sz="2900" dirty="0"/>
           </a:p>
         </p:txBody>
       </p:sp>
@@ -32995,7 +33141,7 @@
         </p:nvSpPr>
         <p:spPr>
           <a:xfrm>
-            <a:off x="548640" y="2931566"/>
+            <a:off x="548640" y="3023921"/>
             <a:ext cx="2601468" cy="274320"/>
           </a:xfrm>
           <a:prstGeom prst="rect">
@@ -33033,7 +33179,7 @@
         </p:nvSpPr>
         <p:spPr>
           <a:xfrm>
-            <a:off x="621792" y="3205886"/>
+            <a:off x="621792" y="3298241"/>
             <a:ext cx="2455164" cy="274320"/>
           </a:xfrm>
           <a:prstGeom prst="rect">
@@ -33088,8 +33234,8 @@
         </p:blipFill>
         <p:spPr>
           <a:xfrm>
-            <a:off x="2711196" y="3214116"/>
-            <a:ext cx="329184" cy="329184"/>
+            <a:off x="2747772" y="1399032"/>
+            <a:ext cx="310896" cy="310896"/>
           </a:xfrm>
           <a:prstGeom prst="rect">
             <a:avLst/>
@@ -33146,8 +33292,8 @@
         </p:blipFill>
         <p:spPr>
           <a:xfrm>
-            <a:off x="4194581" y="1435608"/>
-            <a:ext cx="969721" cy="969721"/>
+            <a:off x="4125316" y="1435608"/>
+            <a:ext cx="1108253" cy="1108253"/>
           </a:xfrm>
           <a:prstGeom prst="rect">
             <a:avLst/>
@@ -33162,8 +33308,8 @@
         </p:nvSpPr>
         <p:spPr>
           <a:xfrm>
-            <a:off x="3378708" y="2423617"/>
-            <a:ext cx="2601468" cy="507949"/>
+            <a:off x="3378708" y="2562149"/>
+            <a:ext cx="2601468" cy="461772"/>
           </a:xfrm>
           <a:prstGeom prst="rect">
             <a:avLst/>
@@ -33181,7 +33327,7 @@
               <a:buNone/>
             </a:pPr>
             <a:r>
-              <a:rPr lang="ko-KR" altLang="en-US" sz="3100" b="1" dirty="0">
+              <a:rPr lang="ko-KR" altLang="en-US" sz="2900" b="1" dirty="0">
                 <a:solidFill>
                   <a:srgbClr val="4236F6"/>
                 </a:solidFill>
@@ -33191,7 +33337,7 @@
               </a:rPr>
               <a:t>김치</a:t>
             </a:r>
-            <a:endParaRPr lang="en-US" sz="3100" dirty="0"/>
+            <a:endParaRPr lang="en-US" sz="2900" dirty="0"/>
           </a:p>
         </p:txBody>
       </p:sp>
@@ -33203,7 +33349,7 @@
         </p:nvSpPr>
         <p:spPr>
           <a:xfrm>
-            <a:off x="3378708" y="2931566"/>
+            <a:off x="3378708" y="3023921"/>
             <a:ext cx="2601468" cy="274320"/>
           </a:xfrm>
           <a:prstGeom prst="rect">
@@ -33241,7 +33387,7 @@
         </p:nvSpPr>
         <p:spPr>
           <a:xfrm>
-            <a:off x="3451860" y="3205886"/>
+            <a:off x="3451860" y="3298241"/>
             <a:ext cx="2455164" cy="274320"/>
           </a:xfrm>
           <a:prstGeom prst="rect">
@@ -33296,8 +33442,8 @@
         </p:blipFill>
         <p:spPr>
           <a:xfrm>
-            <a:off x="5541264" y="3214116"/>
-            <a:ext cx="329184" cy="329184"/>
+            <a:off x="5577840" y="1399032"/>
+            <a:ext cx="310896" cy="310896"/>
           </a:xfrm>
           <a:prstGeom prst="rect">
             <a:avLst/>
@@ -33354,8 +33500,8 @@
         </p:blipFill>
         <p:spPr>
           <a:xfrm>
-            <a:off x="7024649" y="1435608"/>
-            <a:ext cx="969721" cy="969721"/>
+            <a:off x="6955384" y="1435608"/>
+            <a:ext cx="1108253" cy="1108253"/>
           </a:xfrm>
           <a:prstGeom prst="rect">
             <a:avLst/>
@@ -33370,8 +33516,8 @@
         </p:nvSpPr>
         <p:spPr>
           <a:xfrm>
-            <a:off x="6208776" y="2423617"/>
-            <a:ext cx="2601468" cy="507949"/>
+            <a:off x="6208776" y="2562149"/>
+            <a:ext cx="2601468" cy="461772"/>
           </a:xfrm>
           <a:prstGeom prst="rect">
             <a:avLst/>
@@ -33389,7 +33535,7 @@
               <a:buNone/>
             </a:pPr>
             <a:r>
-              <a:rPr lang="ko-KR" altLang="en-US" sz="3100" b="1" dirty="0">
+              <a:rPr lang="ko-KR" altLang="en-US" sz="2900" b="1" dirty="0">
                 <a:solidFill>
                   <a:srgbClr val="4236F6"/>
                 </a:solidFill>
@@ -33399,7 +33545,7 @@
               </a:rPr>
               <a:t>밥</a:t>
             </a:r>
-            <a:endParaRPr lang="en-US" sz="3100" dirty="0"/>
+            <a:endParaRPr lang="en-US" sz="2900" dirty="0"/>
           </a:p>
         </p:txBody>
       </p:sp>
@@ -33411,7 +33557,7 @@
         </p:nvSpPr>
         <p:spPr>
           <a:xfrm>
-            <a:off x="6208776" y="2931566"/>
+            <a:off x="6208776" y="3023921"/>
             <a:ext cx="2601468" cy="274320"/>
           </a:xfrm>
           <a:prstGeom prst="rect">
@@ -33449,7 +33595,7 @@
         </p:nvSpPr>
         <p:spPr>
           <a:xfrm>
-            <a:off x="6281928" y="3205886"/>
+            <a:off x="6281928" y="3298241"/>
             <a:ext cx="2455164" cy="274320"/>
           </a:xfrm>
           <a:prstGeom prst="rect">
@@ -33468,14 +33614,14 @@
               <a:buNone/>
             </a:pPr>
             <a:r>
-              <a:rPr lang="en-US" sz="1600" dirty="0">
+              <a:rPr lang="en-US" sz="1400" dirty="0">
                 <a:solidFill>
                   <a:srgbClr val="5C5F6B"/>
                 </a:solidFill>
               </a:rPr>
               <a:t>arroz cocido; comida</a:t>
             </a:r>
-            <a:endParaRPr lang="en-US" sz="1600" dirty="0"/>
+            <a:endParaRPr lang="en-US" sz="1400" dirty="0"/>
           </a:p>
         </p:txBody>
       </p:sp>
@@ -33504,8 +33650,8 @@
         </p:blipFill>
         <p:spPr>
           <a:xfrm>
-            <a:off x="8371332" y="3214116"/>
-            <a:ext cx="329184" cy="329184"/>
+            <a:off x="8407908" y="1399032"/>
+            <a:ext cx="310896" cy="310896"/>
           </a:xfrm>
           <a:prstGeom prst="rect">
             <a:avLst/>
@@ -33562,8 +33708,8 @@
         </p:blipFill>
         <p:spPr>
           <a:xfrm>
-            <a:off x="9854717" y="1435608"/>
-            <a:ext cx="969721" cy="969721"/>
+            <a:off x="9785452" y="1435608"/>
+            <a:ext cx="1108253" cy="1108253"/>
           </a:xfrm>
           <a:prstGeom prst="rect">
             <a:avLst/>
@@ -33578,8 +33724,8 @@
         </p:nvSpPr>
         <p:spPr>
           <a:xfrm>
-            <a:off x="9038844" y="2423617"/>
-            <a:ext cx="2601468" cy="507949"/>
+            <a:off x="9038844" y="2562149"/>
+            <a:ext cx="2601468" cy="461772"/>
           </a:xfrm>
           <a:prstGeom prst="rect">
             <a:avLst/>
@@ -33597,7 +33743,7 @@
               <a:buNone/>
             </a:pPr>
             <a:r>
-              <a:rPr lang="ko-KR" altLang="en-US" sz="3100" b="1" dirty="0">
+              <a:rPr lang="ko-KR" altLang="en-US" sz="2900" b="1" dirty="0">
                 <a:solidFill>
                   <a:srgbClr val="4236F6"/>
                 </a:solidFill>
@@ -33607,7 +33753,7 @@
               </a:rPr>
               <a:t>사람</a:t>
             </a:r>
-            <a:endParaRPr lang="en-US" sz="3100" dirty="0"/>
+            <a:endParaRPr lang="en-US" sz="2900" dirty="0"/>
           </a:p>
         </p:txBody>
       </p:sp>
@@ -33619,7 +33765,7 @@
         </p:nvSpPr>
         <p:spPr>
           <a:xfrm>
-            <a:off x="9038844" y="2931566"/>
+            <a:off x="9038844" y="3023921"/>
             <a:ext cx="2601468" cy="274320"/>
           </a:xfrm>
           <a:prstGeom prst="rect">
@@ -33657,7 +33803,7 @@
         </p:nvSpPr>
         <p:spPr>
           <a:xfrm>
-            <a:off x="9111996" y="3205886"/>
+            <a:off x="9111996" y="3298241"/>
             <a:ext cx="2455164" cy="274320"/>
           </a:xfrm>
           <a:prstGeom prst="rect">
@@ -33712,8 +33858,8 @@
         </p:blipFill>
         <p:spPr>
           <a:xfrm>
-            <a:off x="11201400" y="3214116"/>
-            <a:ext cx="329184" cy="329184"/>
+            <a:off x="11237976" y="1399032"/>
+            <a:ext cx="310896" cy="310896"/>
           </a:xfrm>
           <a:prstGeom prst="rect">
             <a:avLst/>
@@ -33770,8 +33916,8 @@
         </p:blipFill>
         <p:spPr>
           <a:xfrm>
-            <a:off x="1364513" y="3973068"/>
-            <a:ext cx="969721" cy="969721"/>
+            <a:off x="1295248" y="3973068"/>
+            <a:ext cx="1108253" cy="1108253"/>
           </a:xfrm>
           <a:prstGeom prst="rect">
             <a:avLst/>
@@ -33786,8 +33932,8 @@
         </p:nvSpPr>
         <p:spPr>
           <a:xfrm>
-            <a:off x="548640" y="4961077"/>
-            <a:ext cx="2601468" cy="507949"/>
+            <a:off x="548640" y="5099609"/>
+            <a:ext cx="2601468" cy="461772"/>
           </a:xfrm>
           <a:prstGeom prst="rect">
             <a:avLst/>
@@ -33805,7 +33951,7 @@
               <a:buNone/>
             </a:pPr>
             <a:r>
-              <a:rPr lang="ko-KR" altLang="en-US" sz="3100" b="1" dirty="0">
+              <a:rPr lang="ko-KR" altLang="en-US" sz="2900" b="1" dirty="0">
                 <a:solidFill>
                   <a:srgbClr val="4236F6"/>
                 </a:solidFill>
@@ -33815,7 +33961,7 @@
               </a:rPr>
               <a:t>학생</a:t>
             </a:r>
-            <a:endParaRPr lang="en-US" sz="3100" dirty="0"/>
+            <a:endParaRPr lang="en-US" sz="2900" dirty="0"/>
           </a:p>
         </p:txBody>
       </p:sp>
@@ -33827,7 +33973,7 @@
         </p:nvSpPr>
         <p:spPr>
           <a:xfrm>
-            <a:off x="548640" y="5469026"/>
+            <a:off x="548640" y="5561381"/>
             <a:ext cx="2601468" cy="274320"/>
           </a:xfrm>
           <a:prstGeom prst="rect">
@@ -33865,7 +34011,7 @@
         </p:nvSpPr>
         <p:spPr>
           <a:xfrm>
-            <a:off x="621792" y="5743346"/>
+            <a:off x="621792" y="5835701"/>
             <a:ext cx="2455164" cy="274320"/>
           </a:xfrm>
           <a:prstGeom prst="rect">
@@ -33920,8 +34066,8 @@
         </p:blipFill>
         <p:spPr>
           <a:xfrm>
-            <a:off x="2711196" y="5751576"/>
-            <a:ext cx="329184" cy="329184"/>
+            <a:off x="2747772" y="3936492"/>
+            <a:ext cx="310896" cy="310896"/>
           </a:xfrm>
           <a:prstGeom prst="rect">
             <a:avLst/>
@@ -33978,8 +34124,8 @@
         </p:blipFill>
         <p:spPr>
           <a:xfrm>
-            <a:off x="4194581" y="3973068"/>
-            <a:ext cx="969721" cy="969721"/>
+            <a:off x="4125316" y="3973068"/>
+            <a:ext cx="1108253" cy="1108253"/>
           </a:xfrm>
           <a:prstGeom prst="rect">
             <a:avLst/>
@@ -33994,8 +34140,8 @@
         </p:nvSpPr>
         <p:spPr>
           <a:xfrm>
-            <a:off x="3378708" y="4961077"/>
-            <a:ext cx="2601468" cy="507949"/>
+            <a:off x="3378708" y="5099609"/>
+            <a:ext cx="2601468" cy="461772"/>
           </a:xfrm>
           <a:prstGeom prst="rect">
             <a:avLst/>
@@ -34013,7 +34159,7 @@
               <a:buNone/>
             </a:pPr>
             <a:r>
-              <a:rPr lang="ko-KR" altLang="en-US" sz="3100" b="1" dirty="0">
+              <a:rPr lang="ko-KR" altLang="en-US" sz="2900" b="1" dirty="0">
                 <a:solidFill>
                   <a:srgbClr val="4236F6"/>
                 </a:solidFill>
@@ -34023,7 +34169,7 @@
               </a:rPr>
               <a:t>선생님</a:t>
             </a:r>
-            <a:endParaRPr lang="en-US" sz="3100" dirty="0"/>
+            <a:endParaRPr lang="en-US" sz="2900" dirty="0"/>
           </a:p>
         </p:txBody>
       </p:sp>
@@ -34035,7 +34181,7 @@
         </p:nvSpPr>
         <p:spPr>
           <a:xfrm>
-            <a:off x="3378708" y="5469026"/>
+            <a:off x="3378708" y="5561381"/>
             <a:ext cx="2601468" cy="274320"/>
           </a:xfrm>
           <a:prstGeom prst="rect">
@@ -34073,7 +34219,7 @@
         </p:nvSpPr>
         <p:spPr>
           <a:xfrm>
-            <a:off x="3451860" y="5743346"/>
+            <a:off x="3451860" y="5835701"/>
             <a:ext cx="2455164" cy="274320"/>
           </a:xfrm>
           <a:prstGeom prst="rect">
@@ -34092,14 +34238,14 @@
               <a:buNone/>
             </a:pPr>
             <a:r>
-              <a:rPr lang="en-US" sz="1600" dirty="0">
+              <a:rPr lang="en-US" sz="1400" dirty="0">
                 <a:solidFill>
                   <a:srgbClr val="5C5F6B"/>
                 </a:solidFill>
               </a:rPr>
               <a:t>profesor, profesora</a:t>
             </a:r>
-            <a:endParaRPr lang="en-US" sz="1600" dirty="0"/>
+            <a:endParaRPr lang="en-US" sz="1400" dirty="0"/>
           </a:p>
         </p:txBody>
       </p:sp>
@@ -34128,8 +34274,8 @@
         </p:blipFill>
         <p:spPr>
           <a:xfrm>
-            <a:off x="5541264" y="5751576"/>
-            <a:ext cx="329184" cy="329184"/>
+            <a:off x="5577840" y="3936492"/>
+            <a:ext cx="310896" cy="310896"/>
           </a:xfrm>
           <a:prstGeom prst="rect">
             <a:avLst/>
@@ -34186,8 +34332,8 @@
         </p:blipFill>
         <p:spPr>
           <a:xfrm>
-            <a:off x="7024649" y="3973068"/>
-            <a:ext cx="969721" cy="969721"/>
+            <a:off x="6955384" y="3973068"/>
+            <a:ext cx="1108253" cy="1108253"/>
           </a:xfrm>
           <a:prstGeom prst="rect">
             <a:avLst/>
@@ -34202,8 +34348,8 @@
         </p:nvSpPr>
         <p:spPr>
           <a:xfrm>
-            <a:off x="6208776" y="4961077"/>
-            <a:ext cx="2601468" cy="507949"/>
+            <a:off x="6208776" y="5099609"/>
+            <a:ext cx="2601468" cy="461772"/>
           </a:xfrm>
           <a:prstGeom prst="rect">
             <a:avLst/>
@@ -34221,7 +34367,7 @@
               <a:buNone/>
             </a:pPr>
             <a:r>
-              <a:rPr lang="ko-KR" altLang="en-US" sz="3100" b="1" dirty="0">
+              <a:rPr lang="ko-KR" altLang="en-US" sz="2900" b="1" dirty="0">
                 <a:solidFill>
                   <a:srgbClr val="4236F6"/>
                 </a:solidFill>
@@ -34231,7 +34377,7 @@
               </a:rPr>
               <a:t>칠레</a:t>
             </a:r>
-            <a:endParaRPr lang="en-US" sz="3100" dirty="0"/>
+            <a:endParaRPr lang="en-US" sz="2900" dirty="0"/>
           </a:p>
         </p:txBody>
       </p:sp>
@@ -34243,7 +34389,7 @@
         </p:nvSpPr>
         <p:spPr>
           <a:xfrm>
-            <a:off x="6208776" y="5469026"/>
+            <a:off x="6208776" y="5561381"/>
             <a:ext cx="2601468" cy="274320"/>
           </a:xfrm>
           <a:prstGeom prst="rect">
@@ -34281,7 +34427,7 @@
         </p:nvSpPr>
         <p:spPr>
           <a:xfrm>
-            <a:off x="6281928" y="5743346"/>
+            <a:off x="6281928" y="5835701"/>
             <a:ext cx="2455164" cy="274320"/>
           </a:xfrm>
           <a:prstGeom prst="rect">
@@ -34336,8 +34482,8 @@
         </p:blipFill>
         <p:spPr>
           <a:xfrm>
-            <a:off x="8371332" y="5751576"/>
-            <a:ext cx="329184" cy="329184"/>
+            <a:off x="8407908" y="3936492"/>
+            <a:ext cx="310896" cy="310896"/>
           </a:xfrm>
           <a:prstGeom prst="rect">
             <a:avLst/>
@@ -34750,7 +34896,7 @@
         <p:spPr>
           <a:xfrm>
             <a:off x="548640" y="1325880"/>
-            <a:ext cx="11064240" cy="457200"/>
+            <a:ext cx="11091672" cy="457200"/>
           </a:xfrm>
           <a:prstGeom prst="rect">
             <a:avLst/>
@@ -34953,15 +35099,39 @@
           </a:p>
         </p:txBody>
       </p:sp>
-      <p:sp>
-        <p:nvSpPr>
-          <p:cNvPr id="6" name="Text 4"/>
+      <p:pic>
+        <p:nvPicPr>
+          <p:cNvPr id="6" name="col_img_0" descr="C:\Users\Chingu\AppData\Local\Temp\claude\C--Users-Chingu-Desktop-ACADEMIASEULWEB\d4111e1b-5523-44ea-97b2-b1a1d9545b9e\scratchpad\decks\cache\img_ef9b8592a09691ec.png"/>
+          <p:cNvPicPr>
+            <a:picLocks noChangeAspect="1"/>
+          </p:cNvPicPr>
+          <p:nvPr/>
+        </p:nvPicPr>
+        <p:blipFill>
+          <a:blip r:embed="rId3"/>
+          <a:stretch>
+            <a:fillRect/>
+          </a:stretch>
+        </p:blipFill>
+        <p:spPr>
+          <a:xfrm>
+            <a:off x="2425700" y="2651760"/>
+            <a:ext cx="1631696" cy="741680"/>
+          </a:xfrm>
+          <a:prstGeom prst="rect">
+            <a:avLst/>
+          </a:prstGeom>
+        </p:spPr>
+      </p:pic>
+      <p:sp>
+        <p:nvSpPr>
+          <p:cNvPr id="7" name="Text 4"/>
           <p:cNvSpPr txBox="1"/>
           <p:nvPr/>
         </p:nvSpPr>
         <p:spPr>
           <a:xfrm>
-            <a:off x="777240" y="2651760"/>
+            <a:off x="777240" y="3484880"/>
             <a:ext cx="4928616" cy="914400"/>
           </a:xfrm>
           <a:prstGeom prst="rect">
@@ -35034,14 +35204,14 @@
       </p:sp>
       <p:sp>
         <p:nvSpPr>
-          <p:cNvPr id="7" name="lista"/>
+          <p:cNvPr id="8" name="lista"/>
           <p:cNvSpPr txBox="1"/>
           <p:nvPr/>
         </p:nvSpPr>
         <p:spPr>
           <a:xfrm>
-            <a:off x="731520" y="3657600"/>
-            <a:ext cx="5020056" cy="2377440"/>
+            <a:off x="731520" y="4490720"/>
+            <a:ext cx="5020056" cy="1544320"/>
           </a:xfrm>
           <a:prstGeom prst="rect">
             <a:avLst/>
@@ -35112,7 +35282,7 @@
       </p:sp>
       <p:sp>
         <p:nvSpPr>
-          <p:cNvPr id="8" name="col_1"/>
+          <p:cNvPr id="9" name="col_1"/>
           <p:cNvSpPr/>
           <p:nvPr/>
         </p:nvSpPr>
@@ -35139,7 +35309,7 @@
       </p:sp>
       <p:sp>
         <p:nvSpPr>
-          <p:cNvPr id="9" name="Text 7"/>
+          <p:cNvPr id="10" name="Text 7"/>
           <p:cNvSpPr txBox="1"/>
           <p:nvPr/>
         </p:nvSpPr>
@@ -35186,15 +35356,39 @@
           </a:p>
         </p:txBody>
       </p:sp>
-      <p:sp>
-        <p:nvSpPr>
-          <p:cNvPr id="10" name="Text 8"/>
+      <p:pic>
+        <p:nvPicPr>
+          <p:cNvPr id="11" name="col_img_1" descr="C:\Users\Chingu\AppData\Local\Temp\claude\C--Users-Chingu-Desktop-ACADEMIASEULWEB\d4111e1b-5523-44ea-97b2-b1a1d9545b9e\scratchpad\decks\cache\img_b0997349e833f650.png"/>
+          <p:cNvPicPr>
+            <a:picLocks noChangeAspect="1"/>
+          </p:cNvPicPr>
+          <p:nvPr/>
+        </p:nvPicPr>
+        <p:blipFill>
+          <a:blip r:embed="rId4"/>
+          <a:stretch>
+            <a:fillRect/>
+          </a:stretch>
+        </p:blipFill>
+        <p:spPr>
+          <a:xfrm>
+            <a:off x="8131556" y="2651760"/>
+            <a:ext cx="1631696" cy="741680"/>
+          </a:xfrm>
+          <a:prstGeom prst="rect">
+            <a:avLst/>
+          </a:prstGeom>
+        </p:spPr>
+      </p:pic>
+      <p:sp>
+        <p:nvSpPr>
+          <p:cNvPr id="12" name="Text 8"/>
           <p:cNvSpPr txBox="1"/>
           <p:nvPr/>
         </p:nvSpPr>
         <p:spPr>
           <a:xfrm>
-            <a:off x="6483096" y="2651760"/>
+            <a:off x="6483096" y="3484880"/>
             <a:ext cx="4928616" cy="914400"/>
           </a:xfrm>
           <a:prstGeom prst="rect">
@@ -35267,14 +35461,14 @@
       </p:sp>
       <p:sp>
         <p:nvSpPr>
-          <p:cNvPr id="11" name="lista"/>
+          <p:cNvPr id="13" name="lista"/>
           <p:cNvSpPr txBox="1"/>
           <p:nvPr/>
         </p:nvSpPr>
         <p:spPr>
           <a:xfrm>
-            <a:off x="6437376" y="3657600"/>
-            <a:ext cx="5020056" cy="2377440"/>
+            <a:off x="6437376" y="4490720"/>
+            <a:ext cx="5020056" cy="1544320"/>
           </a:xfrm>
           <a:prstGeom prst="rect">
             <a:avLst/>
@@ -35464,16 +35658,40 @@
           </a:p>
         </p:txBody>
       </p:sp>
-      <p:sp>
-        <p:nvSpPr>
-          <p:cNvPr id="3" name="Text 1"/>
+      <p:pic>
+        <p:nvPicPr>
+          <p:cNvPr id="3" name="imagen" descr="C:\Users\Chingu\AppData\Local\Temp\claude\C--Users-Chingu-Desktop-ACADEMIASEULWEB\d4111e1b-5523-44ea-97b2-b1a1d9545b9e\scratchpad\decks\cache\img_76f3046b7afc1121.png"/>
+          <p:cNvPicPr>
+            <a:picLocks noChangeAspect="1"/>
+          </p:cNvPicPr>
+          <p:nvPr/>
+        </p:nvPicPr>
+        <p:blipFill>
+          <a:blip r:embed="rId3"/>
+          <a:stretch>
+            <a:fillRect/>
+          </a:stretch>
+        </p:blipFill>
+        <p:spPr>
+          <a:xfrm>
+            <a:off x="7754112" y="1508760"/>
+            <a:ext cx="3886200" cy="4480560"/>
+          </a:xfrm>
+          <a:prstGeom prst="rect">
+            <a:avLst/>
+          </a:prstGeom>
+        </p:spPr>
+      </p:pic>
+      <p:sp>
+        <p:nvSpPr>
+          <p:cNvPr id="4" name="Text 1"/>
           <p:cNvSpPr txBox="1"/>
           <p:nvPr/>
         </p:nvSpPr>
         <p:spPr>
           <a:xfrm>
             <a:off x="548640" y="1325880"/>
-            <a:ext cx="11064240" cy="457200"/>
+            <a:ext cx="6931152" cy="457200"/>
           </a:xfrm>
           <a:prstGeom prst="rect">
             <a:avLst/>
@@ -35541,35 +35759,35 @@
           <p:nvPr>
             <p:extLst>
               <p:ext uri="{D42A27DB-BD31-4B8C-83A1-F6EECF244321}">
-                <p14:modId xmlns:p14="http://schemas.microsoft.com/office/powerpoint/2010/main" val="3120003089"/>
+                <p14:modId xmlns:p14="http://schemas.microsoft.com/office/powerpoint/2010/main" val="2111213551"/>
               </p:ext>
             </p:extLst>
           </p:nvPr>
         </p:nvGraphicFramePr>
         <p:xfrm>
           <a:off x="548640" y="1874520"/>
-          <a:ext cx="11091672" cy="914400"/>
+          <a:ext cx="6931152" cy="914400"/>
         </p:xfrm>
         <a:graphic>
           <a:graphicData uri="http://schemas.openxmlformats.org/drawingml/2006/table">
             <a:tbl>
               <a:tblPr/>
               <a:tblGrid>
-                <a:gridCol w="3697224">
+                <a:gridCol w="2310384">
                   <a:extLst>
                     <a:ext uri="{9D8B030D-6E8A-4147-A177-3AD203B41FA5}">
                       <a16:colId xmlns:a16="http://schemas.microsoft.com/office/drawing/2014/main" val="20000"/>
                     </a:ext>
                   </a:extLst>
                 </a:gridCol>
-                <a:gridCol w="3697224">
+                <a:gridCol w="2310384">
                   <a:extLst>
                     <a:ext uri="{9D8B030D-6E8A-4147-A177-3AD203B41FA5}">
                       <a16:colId xmlns:a16="http://schemas.microsoft.com/office/drawing/2014/main" val="20001"/>
                     </a:ext>
                   </a:extLst>
                 </a:gridCol>
-                <a:gridCol w="3697224">
+                <a:gridCol w="2310384">
                   <a:extLst>
                     <a:ext uri="{9D8B030D-6E8A-4147-A177-3AD203B41FA5}">
                       <a16:colId xmlns:a16="http://schemas.microsoft.com/office/drawing/2014/main" val="20002"/>

</xml_diff>